<commit_message>
feat(vigencia): modulo de configuracion de avisos y notificaciones de vigencia LFT con cron diario y auditoria de envios
</commit_message>
<xml_diff>
--- a/DOCS/Diagrama_Flujo_Vacaciones_JAMA_Redisenado 1.pptx
+++ b/DOCS/Diagrama_Flujo_Vacaciones_JAMA_Redisenado 1.pptx
@@ -5,7 +5,7 @@
     <p:sldMasterId id="2147483648" r:id="rId1"/>
   </p:sldMasterIdLst>
   <p:notesMasterIdLst>
-    <p:notesMasterId r:id="rId7"/>
+    <p:notesMasterId r:id="rId9"/>
   </p:notesMasterIdLst>
   <p:sldIdLst>
     <p:sldId id="256" r:id="rId2"/>
@@ -13,6 +13,8 @@
     <p:sldId id="258" r:id="rId4"/>
     <p:sldId id="259" r:id="rId5"/>
     <p:sldId id="260" r:id="rId6"/>
+    <p:sldId id="261" r:id="rId7"/>
+    <p:sldId id="262" r:id="rId8"/>
   </p:sldIdLst>
   <p:sldSz cx="12192000" cy="6858000"/>
   <p:notesSz cx="6858000" cy="12192000"/>
@@ -108,6 +110,11 @@
       </a:defRPr>
     </a:lvl9pPr>
   </p:defaultTextStyle>
+  <p:extLst>
+    <p:ext uri="{EFAFB233-063F-42B5-8137-9DF3F51BA10A}">
+      <p15:sldGuideLst xmlns:p15="http://schemas.microsoft.com/office/powerpoint/2012/main"/>
+    </p:ext>
+  </p:extLst>
 </p:presentation>
 </file>
 
@@ -133,234 +140,10 @@
           <a:chExt cx="0" cy="0"/>
         </a:xfrm>
       </p:grpSpPr>
-      <p:sp>
-        <p:nvSpPr>
-          <p:cNvPr id="2" name="Header Placeholder 1"/>
-          <p:cNvSpPr>
-            <a:spLocks noGrp="1"/>
-          </p:cNvSpPr>
-          <p:nvPr>
-            <p:ph type="hdr" sz="quarter"/>
-          </p:nvPr>
-        </p:nvSpPr>
-        <p:spPr>
-          <a:xfrm>
-            <a:off x="0" y="0"/>
-            <a:ext cx="2971800" cy="458788"/>
-          </a:xfrm>
-          <a:prstGeom prst="rect">
-            <a:avLst/>
-          </a:prstGeom>
-        </p:spPr>
-        <p:txBody>
-          <a:bodyPr vert="horz" lIns="91440" tIns="45720" rIns="91440" bIns="45720" rtlCol="0"/>
-          <a:lstStyle>
-            <a:lvl1pPr algn="l">
-              <a:defRPr sz="1200"/>
-            </a:lvl1pPr>
-          </a:lstStyle>
-          <a:p>
-            <a:endParaRPr lang="en-US"/>
-          </a:p>
-        </p:txBody>
-      </p:sp>
-      <p:sp>
-        <p:nvSpPr>
-          <p:cNvPr id="3" name="Date Placeholder 2"/>
-          <p:cNvSpPr>
-            <a:spLocks noGrp="1"/>
-          </p:cNvSpPr>
-          <p:nvPr>
-            <p:ph type="dt" idx="1"/>
-          </p:nvPr>
-        </p:nvSpPr>
-        <p:spPr>
-          <a:xfrm>
-            <a:off x="3884613" y="0"/>
-            <a:ext cx="2971800" cy="458788"/>
-          </a:xfrm>
-          <a:prstGeom prst="rect">
-            <a:avLst/>
-          </a:prstGeom>
-        </p:spPr>
-        <p:txBody>
-          <a:bodyPr vert="horz" lIns="91440" tIns="45720" rIns="91440" bIns="45720" rtlCol="0"/>
-          <a:lstStyle>
-            <a:lvl1pPr algn="r">
-              <a:defRPr sz="1200"/>
-            </a:lvl1pPr>
-          </a:lstStyle>
-          <a:p>
-            <a:fld id="{5282F153-3F37-0F45-9E97-73ACFA13230C}" type="datetimeFigureOut">
-              <a:rPr lang="en-US"/>
-              <a:t>7/23/19</a:t>
-            </a:fld>
-            <a:endParaRPr lang="en-US"/>
-          </a:p>
-        </p:txBody>
-      </p:sp>
-      <p:sp>
-        <p:nvSpPr>
-          <p:cNvPr id="4" name="Slide Image Placeholder 3"/>
-          <p:cNvSpPr>
-            <a:spLocks noGrp="1" noRot="1" noChangeAspect="1"/>
-          </p:cNvSpPr>
-          <p:nvPr>
-            <p:ph type="sldImg" idx="2"/>
-          </p:nvPr>
-        </p:nvSpPr>
-        <p:spPr>
-          <a:xfrm>
-            <a:off x="685800" y="1143000"/>
-            <a:ext cx="5486400" cy="3086100"/>
-          </a:xfrm>
-          <a:prstGeom prst="rect">
-            <a:avLst/>
-          </a:prstGeom>
-          <a:noFill/>
-          <a:ln w="12700">
-            <a:solidFill>
-              <a:prstClr val="black"/>
-            </a:solidFill>
-          </a:ln>
-        </p:spPr>
-        <p:txBody>
-          <a:bodyPr vert="horz" lIns="91440" tIns="45720" rIns="91440" bIns="45720" rtlCol="0" anchor="ctr"/>
-          <a:lstStyle/>
-          <a:p>
-            <a:endParaRPr lang="en-US"/>
-          </a:p>
-        </p:txBody>
-      </p:sp>
-      <p:sp>
-        <p:nvSpPr>
-          <p:cNvPr id="5" name="Notes Placeholder 4"/>
-          <p:cNvSpPr>
-            <a:spLocks noGrp="1"/>
-          </p:cNvSpPr>
-          <p:nvPr>
-            <p:ph type="body" sz="quarter" idx="3"/>
-          </p:nvPr>
-        </p:nvSpPr>
-        <p:spPr>
-          <a:xfrm>
-            <a:off x="685800" y="4400550"/>
-            <a:ext cx="5486400" cy="3600450"/>
-          </a:xfrm>
-          <a:prstGeom prst="rect">
-            <a:avLst/>
-          </a:prstGeom>
-        </p:spPr>
-        <p:txBody>
-          <a:bodyPr vert="horz" lIns="91440" tIns="45720" rIns="91440" bIns="45720" rtlCol="0"/>
-          <a:lstStyle/>
-          <a:p>
-            <a:pPr lvl="0"/>
-            <a:r>
-              <a:rPr lang="en-US"/>
-              <a:t>Click to edit Master text styles</a:t>
-            </a:r>
-          </a:p>
-          <a:p>
-            <a:pPr lvl="1"/>
-            <a:r>
-              <a:rPr lang="en-US"/>
-              <a:t>Second level</a:t>
-            </a:r>
-          </a:p>
-          <a:p>
-            <a:pPr lvl="2"/>
-            <a:r>
-              <a:rPr lang="en-US"/>
-              <a:t>Third level</a:t>
-            </a:r>
-          </a:p>
-          <a:p>
-            <a:pPr lvl="3"/>
-            <a:r>
-              <a:rPr lang="en-US"/>
-              <a:t>Fourth level</a:t>
-            </a:r>
-          </a:p>
-          <a:p>
-            <a:pPr lvl="4"/>
-            <a:r>
-              <a:rPr lang="en-US"/>
-              <a:t>Fifth level</a:t>
-            </a:r>
-          </a:p>
-        </p:txBody>
-      </p:sp>
-      <p:sp>
-        <p:nvSpPr>
-          <p:cNvPr id="6" name="Footer Placeholder 5"/>
-          <p:cNvSpPr>
-            <a:spLocks noGrp="1"/>
-          </p:cNvSpPr>
-          <p:nvPr>
-            <p:ph type="ftr" sz="quarter" idx="4"/>
-          </p:nvPr>
-        </p:nvSpPr>
-        <p:spPr>
-          <a:xfrm>
-            <a:off x="0" y="8685213"/>
-            <a:ext cx="2971800" cy="458787"/>
-          </a:xfrm>
-          <a:prstGeom prst="rect">
-            <a:avLst/>
-          </a:prstGeom>
-        </p:spPr>
-        <p:txBody>
-          <a:bodyPr vert="horz" lIns="91440" tIns="45720" rIns="91440" bIns="45720" rtlCol="0" anchor="b"/>
-          <a:lstStyle>
-            <a:lvl1pPr algn="l">
-              <a:defRPr sz="1200"/>
-            </a:lvl1pPr>
-          </a:lstStyle>
-          <a:p>
-            <a:endParaRPr lang="en-US"/>
-          </a:p>
-        </p:txBody>
-      </p:sp>
-      <p:sp>
-        <p:nvSpPr>
-          <p:cNvPr id="7" name="Slide Number Placeholder 6"/>
-          <p:cNvSpPr>
-            <a:spLocks noGrp="1"/>
-          </p:cNvSpPr>
-          <p:nvPr>
-            <p:ph type="sldNum" sz="quarter" idx="5"/>
-          </p:nvPr>
-        </p:nvSpPr>
-        <p:spPr>
-          <a:xfrm>
-            <a:off x="3884613" y="8685213"/>
-            <a:ext cx="2971800" cy="458787"/>
-          </a:xfrm>
-          <a:prstGeom prst="rect">
-            <a:avLst/>
-          </a:prstGeom>
-        </p:spPr>
-        <p:txBody>
-          <a:bodyPr vert="horz" lIns="91440" tIns="45720" rIns="91440" bIns="45720" rtlCol="0" anchor="b"/>
-          <a:lstStyle>
-            <a:lvl1pPr algn="r">
-              <a:defRPr sz="1200"/>
-            </a:lvl1pPr>
-          </a:lstStyle>
-          <a:p>
-            <a:fld id="{CE5E9CC1-C706-0F49-92D6-E571CC5EEA8F}" type="slidenum">
-              <a:rPr lang="en-US"/>
-              <a:t>‹#›</a:t>
-            </a:fld>
-            <a:endParaRPr lang="en-US"/>
-          </a:p>
-        </p:txBody>
-      </p:sp>
     </p:spTree>
     <p:extLst>
       <p:ext uri="{BB962C8B-B14F-4D97-AF65-F5344CB8AC3E}">
-        <p14:creationId xmlns:p14="http://schemas.microsoft.com/office/powerpoint/2010/main" val="1024086991"/>
+        <p14:creationId xmlns:p14="http://schemas.microsoft.com/office/powerpoint/2010/main" val="3679080155"/>
       </p:ext>
     </p:extLst>
   </p:cSld>
@@ -510,7 +293,6 @@
 - Internal source: Diagrama_Flujo_Solicitudes_Vacaciones_Grupo_JAMA.pptx
 [/Sources]</a:t>
             </a:r>
-            <a:endParaRPr lang="en-US" dirty="0"/>
           </a:p>
         </p:txBody>
       </p:sp>
@@ -600,7 +382,6 @@
 - Internal source: Diagrama_Flujo_Solicitudes_Vacaciones_Grupo_JAMA.pptx
 [/Sources]</a:t>
             </a:r>
-            <a:endParaRPr lang="en-US" dirty="0"/>
           </a:p>
         </p:txBody>
       </p:sp>
@@ -690,7 +471,6 @@
 - Internal source: Diagrama_Flujo_Solicitudes_Vacaciones_Grupo_JAMA.pptx
 [/Sources]</a:t>
             </a:r>
-            <a:endParaRPr lang="en-US" dirty="0"/>
           </a:p>
         </p:txBody>
       </p:sp>
@@ -780,7 +560,6 @@
 - Internal source: Diagrama_Flujo_Solicitudes_Vacaciones_Grupo_JAMA.pptx
 [/Sources]</a:t>
             </a:r>
-            <a:endParaRPr lang="en-US" dirty="0"/>
           </a:p>
         </p:txBody>
       </p:sp>
@@ -870,7 +649,6 @@
 - Internal source: Diagrama_Flujo_Solicitudes_Vacaciones_Grupo_JAMA.pptx
 [/Sources]</a:t>
             </a:r>
-            <a:endParaRPr lang="en-US" dirty="0"/>
           </a:p>
         </p:txBody>
       </p:sp>
@@ -903,6 +681,146 @@
         <p14:creationId xmlns:p14="http://schemas.microsoft.com/office/powerpoint/2010/main" val="1024086991"/>
       </p:ext>
     </p:extLst>
+  </p:cSld>
+  <p:clrMapOvr>
+    <a:masterClrMapping/>
+  </p:clrMapOvr>
+</p:notes>
+</file>
+
+<file path=ppt/notesSlides/notesSlide6.xml><?xml version="1.0" encoding="utf-8"?>
+<p:notes xmlns:a="http://schemas.openxmlformats.org/drawingml/2006/main" xmlns:r="http://schemas.openxmlformats.org/officeDocument/2006/relationships" xmlns:p="http://schemas.openxmlformats.org/presentationml/2006/main">
+  <p:cSld>
+    <p:spTree>
+      <p:nvGrpSpPr>
+        <p:cNvPr id="1" name=""/>
+        <p:cNvGrpSpPr/>
+        <p:nvPr/>
+      </p:nvGrpSpPr>
+      <p:grpSpPr>
+        <a:xfrm>
+          <a:off x="0" y="0"/>
+          <a:ext cx="0" cy="0"/>
+          <a:chOff x="0" y="0"/>
+          <a:chExt cx="0" cy="0"/>
+        </a:xfrm>
+      </p:grpSpPr>
+      <p:sp>
+        <p:nvSpPr>
+          <p:cNvPr id="2" name="Slide Image Placeholder 1"/>
+          <p:cNvSpPr>
+            <a:spLocks noGrp="1" noRot="1" noChangeAspect="1"/>
+          </p:cNvSpPr>
+          <p:nvPr>
+            <p:ph type="sldImg" idx="2"/>
+          </p:nvPr>
+        </p:nvSpPr>
+        <p:spPr/>
+      </p:sp>
+      <p:sp>
+        <p:nvSpPr>
+          <p:cNvPr id="3" name="Notes Placeholder 2"/>
+          <p:cNvSpPr>
+            <a:spLocks noGrp="1"/>
+          </p:cNvSpPr>
+          <p:nvPr>
+            <p:ph type="body" sz="quarter" idx="3"/>
+          </p:nvPr>
+        </p:nvSpPr>
+        <p:spPr/>
+        <p:txBody>
+          <a:bodyPr/>
+          <a:lstStyle/>
+          <a:p>
+            <a:r>
+              <a:t>Fuente: contenido proporcionado por el usuario. Se describe la lógica indicada para el sistema, incluida su regla de vigencia de 18 meses. El ciclo 2025–2026 es un ejemplo ilustrativo.</a:t>
+            </a:r>
+          </a:p>
+        </p:txBody>
+      </p:sp>
+      <p:sp>
+        <p:nvSpPr>
+          <p:cNvPr id="4" name="Slide Number Placeholder 3"/>
+          <p:cNvSpPr>
+            <a:spLocks noGrp="1"/>
+          </p:cNvSpPr>
+          <p:nvPr>
+            <p:ph type="sldNum" sz="quarter" idx="5"/>
+          </p:nvPr>
+        </p:nvSpPr>
+        <p:spPr/>
+      </p:sp>
+    </p:spTree>
+  </p:cSld>
+  <p:clrMapOvr>
+    <a:masterClrMapping/>
+  </p:clrMapOvr>
+</p:notes>
+</file>
+
+<file path=ppt/notesSlides/notesSlide7.xml><?xml version="1.0" encoding="utf-8"?>
+<p:notes xmlns:a="http://schemas.openxmlformats.org/drawingml/2006/main" xmlns:r="http://schemas.openxmlformats.org/officeDocument/2006/relationships" xmlns:p="http://schemas.openxmlformats.org/presentationml/2006/main">
+  <p:cSld>
+    <p:spTree>
+      <p:nvGrpSpPr>
+        <p:cNvPr id="1" name=""/>
+        <p:cNvGrpSpPr/>
+        <p:nvPr/>
+      </p:nvGrpSpPr>
+      <p:grpSpPr>
+        <a:xfrm>
+          <a:off x="0" y="0"/>
+          <a:ext cx="0" cy="0"/>
+          <a:chOff x="0" y="0"/>
+          <a:chExt cx="0" cy="0"/>
+        </a:xfrm>
+      </p:grpSpPr>
+      <p:sp>
+        <p:nvSpPr>
+          <p:cNvPr id="2" name="Slide Image Placeholder 1"/>
+          <p:cNvSpPr>
+            <a:spLocks noGrp="1" noRot="1" noChangeAspect="1"/>
+          </p:cNvSpPr>
+          <p:nvPr>
+            <p:ph type="sldImg" idx="2"/>
+          </p:nvPr>
+        </p:nvSpPr>
+        <p:spPr/>
+      </p:sp>
+      <p:sp>
+        <p:nvSpPr>
+          <p:cNvPr id="3" name="Notes Placeholder 2"/>
+          <p:cNvSpPr>
+            <a:spLocks noGrp="1"/>
+          </p:cNvSpPr>
+          <p:nvPr>
+            <p:ph type="body" sz="quarter" idx="3"/>
+          </p:nvPr>
+        </p:nvSpPr>
+        <p:spPr/>
+        <p:txBody>
+          <a:bodyPr/>
+          <a:lstStyle/>
+          <a:p>
+            <a:r>
+              <a:t>Fuente: contenido proporcionado por el usuario. La actualización del estatus se sincroniza desde nómina. No se especifica una regla adicional de liquidación o cancelación de saldos por baja.</a:t>
+            </a:r>
+          </a:p>
+        </p:txBody>
+      </p:sp>
+      <p:sp>
+        <p:nvSpPr>
+          <p:cNvPr id="4" name="Slide Number Placeholder 3"/>
+          <p:cNvSpPr>
+            <a:spLocks noGrp="1"/>
+          </p:cNvSpPr>
+          <p:nvPr>
+            <p:ph type="sldNum" sz="quarter" idx="5"/>
+          </p:nvPr>
+        </p:nvSpPr>
+        <p:spPr/>
+      </p:sp>
+    </p:spTree>
   </p:cSld>
   <p:clrMapOvr>
     <a:masterClrMapping/>
@@ -943,6 +861,11 @@
 <file path=ppt/slideMasters/slideMaster1.xml><?xml version="1.0" encoding="utf-8"?>
 <p:sldMaster xmlns:a="http://schemas.openxmlformats.org/drawingml/2006/main" xmlns:r="http://schemas.openxmlformats.org/officeDocument/2006/relationships" xmlns:p="http://schemas.openxmlformats.org/presentationml/2006/main">
   <p:cSld>
+    <p:bg>
+      <p:bgRef idx="1001">
+        <a:schemeClr val="bg1"/>
+      </p:bgRef>
+    </p:bg>
     <p:spTree>
       <p:nvGrpSpPr>
         <p:cNvPr id="1" name=""/>
@@ -1225,6 +1148,7 @@
         <a:solidFill>
           <a:srgbClr val="002D62"/>
         </a:solidFill>
+        <a:effectLst/>
       </p:bgPr>
     </p:bg>
     <p:spTree>
@@ -1267,6 +1191,13 @@
             <a:prstDash val="solid"/>
           </a:ln>
         </p:spPr>
+        <p:txBody>
+          <a:bodyPr/>
+          <a:lstStyle/>
+          <a:p>
+            <a:endParaRPr lang="es-MX"/>
+          </a:p>
+        </p:txBody>
       </p:sp>
       <p:sp>
         <p:nvSpPr>
@@ -1296,17 +1227,24 @@
             <a:prstDash val="solid"/>
           </a:ln>
         </p:spPr>
+        <p:txBody>
+          <a:bodyPr/>
+          <a:lstStyle/>
+          <a:p>
+            <a:endParaRPr lang="es-MX"/>
+          </a:p>
+        </p:txBody>
       </p:sp>
       <p:pic>
         <p:nvPicPr>
-          <p:cNvPr id="4" name="Image 0" descr="/mnt/data/work_jama/ppt/media/image1.png">    </p:cNvPr>
+          <p:cNvPr id="4" name="Image 0" descr="/mnt/data/work_jama/ppt/media/image1.png"/>
           <p:cNvPicPr>
             <a:picLocks noChangeAspect="1"/>
           </p:cNvPicPr>
           <p:nvPr/>
         </p:nvPicPr>
         <p:blipFill>
-          <a:blip r:embed="rId1"/>
+          <a:blip r:embed="rId3"/>
           <a:stretch>
             <a:fillRect/>
           </a:stretch>
@@ -1320,6 +1258,20 @@
             <a:avLst/>
           </a:prstGeom>
         </p:spPr>
+        <p:style>
+          <a:lnRef idx="2">
+            <a:schemeClr val="dk1"/>
+          </a:lnRef>
+          <a:fillRef idx="1">
+            <a:schemeClr val="lt1"/>
+          </a:fillRef>
+          <a:effectRef idx="0">
+            <a:schemeClr val="dk1"/>
+          </a:effectRef>
+          <a:fontRef idx="minor">
+            <a:schemeClr val="dk1"/>
+          </a:fontRef>
+        </p:style>
       </p:pic>
       <p:sp>
         <p:nvSpPr>
@@ -1344,11 +1296,11 @@
           </a:bodyPr>
           <a:lstStyle/>
           <a:p>
-            <a:pPr indent="0" marL="0">
-              <a:buNone/>
-            </a:pPr>
-            <a:r>
-              <a:rPr lang="en-US" sz="1100" b="1" spc="200" kern="0" dirty="0">
+            <a:pPr marL="0" indent="0">
+              <a:buNone/>
+            </a:pPr>
+            <a:r>
+              <a:rPr lang="en-US" sz="1100" b="1" kern="0" spc="200" dirty="0">
                 <a:solidFill>
                   <a:srgbClr val="A2B7C4"/>
                 </a:solidFill>
@@ -1385,7 +1337,7 @@
           </a:bodyPr>
           <a:lstStyle/>
           <a:p>
-            <a:pPr indent="0" marL="0">
+            <a:pPr marL="0" indent="0">
               <a:buNone/>
             </a:pPr>
             <a:r>
@@ -1402,7 +1354,7 @@
             <a:endParaRPr lang="en-US" sz="3100" dirty="0"/>
           </a:p>
           <a:p>
-            <a:pPr indent="0" marL="0">
+            <a:pPr marL="0" indent="0">
               <a:buNone/>
             </a:pPr>
             <a:r>
@@ -1443,7 +1395,7 @@
           </a:bodyPr>
           <a:lstStyle/>
           <a:p>
-            <a:pPr indent="0" marL="0">
+            <a:pPr marL="0" indent="0">
               <a:buNone/>
             </a:pPr>
             <a:r>
@@ -1485,6 +1437,13 @@
             <a:prstDash val="solid"/>
           </a:ln>
         </p:spPr>
+        <p:txBody>
+          <a:bodyPr/>
+          <a:lstStyle/>
+          <a:p>
+            <a:endParaRPr lang="es-MX"/>
+          </a:p>
+        </p:txBody>
       </p:sp>
       <p:sp>
         <p:nvSpPr>
@@ -1509,11 +1468,11 @@
           </a:bodyPr>
           <a:lstStyle/>
           <a:p>
-            <a:pPr indent="0" marL="0">
-              <a:buNone/>
-            </a:pPr>
-            <a:r>
-              <a:rPr lang="en-US" sz="1000" b="1" spc="80" kern="0" dirty="0">
+            <a:pPr marL="0" indent="0">
+              <a:buNone/>
+            </a:pPr>
+            <a:r>
+              <a:rPr lang="en-US" sz="1000" b="1" kern="0" spc="80" dirty="0">
                 <a:solidFill>
                   <a:srgbClr val="FFFFFF"/>
                 </a:solidFill>
@@ -1551,6 +1510,13 @@
             <a:prstDash val="solid"/>
           </a:ln>
         </p:spPr>
+        <p:txBody>
+          <a:bodyPr/>
+          <a:lstStyle/>
+          <a:p>
+            <a:endParaRPr lang="es-MX"/>
+          </a:p>
+        </p:txBody>
       </p:sp>
       <p:sp>
         <p:nvSpPr>
@@ -1575,11 +1541,11 @@
           </a:bodyPr>
           <a:lstStyle/>
           <a:p>
-            <a:pPr indent="0" marL="0">
-              <a:buNone/>
-            </a:pPr>
-            <a:r>
-              <a:rPr lang="en-US" sz="1000" b="1" spc="80" kern="0" dirty="0">
+            <a:pPr marL="0" indent="0">
+              <a:buNone/>
+            </a:pPr>
+            <a:r>
+              <a:rPr lang="en-US" sz="1000" b="1" kern="0" spc="80" dirty="0">
                 <a:solidFill>
                   <a:srgbClr val="FFFFFF"/>
                 </a:solidFill>
@@ -1617,6 +1583,13 @@
             <a:prstDash val="solid"/>
           </a:ln>
         </p:spPr>
+        <p:txBody>
+          <a:bodyPr/>
+          <a:lstStyle/>
+          <a:p>
+            <a:endParaRPr lang="es-MX"/>
+          </a:p>
+        </p:txBody>
       </p:sp>
       <p:sp>
         <p:nvSpPr>
@@ -1641,11 +1614,11 @@
           </a:bodyPr>
           <a:lstStyle/>
           <a:p>
-            <a:pPr indent="0" marL="0">
-              <a:buNone/>
-            </a:pPr>
-            <a:r>
-              <a:rPr lang="en-US" sz="1000" b="1" spc="80" kern="0" dirty="0">
+            <a:pPr marL="0" indent="0">
+              <a:buNone/>
+            </a:pPr>
+            <a:r>
+              <a:rPr lang="en-US" sz="1000" b="1" kern="0" spc="80" dirty="0">
                 <a:solidFill>
                   <a:srgbClr val="FFFFFF"/>
                 </a:solidFill>
@@ -1682,7 +1655,7 @@
           </a:bodyPr>
           <a:lstStyle/>
           <a:p>
-            <a:pPr algn="r" indent="0" marL="0">
+            <a:pPr marL="0" indent="0" algn="r">
               <a:buNone/>
             </a:pPr>
             <a:r>
@@ -1716,6 +1689,7 @@
         <a:solidFill>
           <a:srgbClr val="FFFFFF"/>
         </a:solidFill>
+        <a:effectLst/>
       </p:bgPr>
     </p:bg>
     <p:spTree>
@@ -1756,6 +1730,13 @@
             <a:prstDash val="solid"/>
           </a:ln>
         </p:spPr>
+        <p:txBody>
+          <a:bodyPr/>
+          <a:lstStyle/>
+          <a:p>
+            <a:endParaRPr lang="es-MX"/>
+          </a:p>
+        </p:txBody>
       </p:sp>
       <p:sp>
         <p:nvSpPr>
@@ -1778,11 +1759,11 @@
           <a:bodyPr wrap="square" lIns="0" tIns="0" rIns="0" bIns="0" rtlCol="0" anchor="ctr"/>
           <a:lstStyle/>
           <a:p>
-            <a:pPr indent="0" marL="0">
-              <a:buNone/>
-            </a:pPr>
-            <a:r>
-              <a:rPr lang="en-US" sz="900" b="1" spc="120" kern="0" dirty="0">
+            <a:pPr marL="0" indent="0">
+              <a:buNone/>
+            </a:pPr>
+            <a:r>
+              <a:rPr lang="en-US" sz="900" b="1" kern="0" spc="120" dirty="0">
                 <a:solidFill>
                   <a:srgbClr val="5B8296"/>
                 </a:solidFill>
@@ -1817,7 +1798,7 @@
           <a:bodyPr wrap="square" lIns="0" tIns="0" rIns="0" bIns="0" rtlCol="0" anchor="ctr"/>
           <a:lstStyle/>
           <a:p>
-            <a:pPr indent="0" marL="0">
+            <a:pPr marL="0" indent="0">
               <a:buNone/>
             </a:pPr>
             <a:r>
@@ -1837,14 +1818,14 @@
       </p:sp>
       <p:pic>
         <p:nvPicPr>
-          <p:cNvPr id="5" name="Image 0" descr="/mnt/data/work_jama/ppt/media/image1.png">    </p:cNvPr>
+          <p:cNvPr id="5" name="Image 0" descr="/mnt/data/work_jama/ppt/media/image1.png"/>
           <p:cNvPicPr>
             <a:picLocks noChangeAspect="1"/>
           </p:cNvPicPr>
           <p:nvPr/>
         </p:nvPicPr>
         <p:blipFill>
-          <a:blip r:embed="rId1"/>
+          <a:blip r:embed="rId3"/>
           <a:stretch>
             <a:fillRect/>
           </a:stretch>
@@ -1880,7 +1861,7 @@
           <a:bodyPr wrap="square" lIns="0" tIns="0" rIns="0" bIns="0" rtlCol="0" anchor="ctr"/>
           <a:lstStyle/>
           <a:p>
-            <a:pPr algn="r" indent="0" marL="0">
+            <a:pPr marL="0" indent="0" algn="r">
               <a:buNone/>
             </a:pPr>
             <a:r>
@@ -1917,6 +1898,13 @@
             <a:prstDash val="solid"/>
           </a:ln>
         </p:spPr>
+        <p:txBody>
+          <a:bodyPr/>
+          <a:lstStyle/>
+          <a:p>
+            <a:endParaRPr lang="es-MX"/>
+          </a:p>
+        </p:txBody>
       </p:sp>
       <p:sp>
         <p:nvSpPr>
@@ -1944,13 +1932,20 @@
             <a:prstDash val="solid"/>
           </a:ln>
           <a:effectLst>
-            <a:outerShdw sx="100000" sy="100000" kx="0" ky="0" algn="bl" rotWithShape="0" blurRad="12700" dist="50800" dir="2700000">
+            <a:outerShdw blurRad="12700" dist="50800" dir="2700000" algn="bl" rotWithShape="0">
               <a:srgbClr val="B8C5CF">
                 <a:alpha val="14000"/>
               </a:srgbClr>
             </a:outerShdw>
           </a:effectLst>
         </p:spPr>
+        <p:txBody>
+          <a:bodyPr/>
+          <a:lstStyle/>
+          <a:p>
+            <a:endParaRPr lang="es-MX"/>
+          </a:p>
+        </p:txBody>
       </p:sp>
       <p:sp>
         <p:nvSpPr>
@@ -1978,6 +1973,13 @@
             <a:prstDash val="solid"/>
           </a:ln>
         </p:spPr>
+        <p:txBody>
+          <a:bodyPr/>
+          <a:lstStyle/>
+          <a:p>
+            <a:endParaRPr lang="es-MX"/>
+          </a:p>
+        </p:txBody>
       </p:sp>
       <p:sp>
         <p:nvSpPr>
@@ -2002,7 +2004,7 @@
           </a:bodyPr>
           <a:lstStyle/>
           <a:p>
-            <a:pPr algn="ctr" indent="0" marL="0">
+            <a:pPr marL="0" indent="0" algn="ctr">
               <a:buNone/>
             </a:pPr>
             <a:r>
@@ -2043,7 +2045,7 @@
           </a:bodyPr>
           <a:lstStyle/>
           <a:p>
-            <a:pPr indent="0" marL="0">
+            <a:pPr marL="0" indent="0">
               <a:buNone/>
             </a:pPr>
             <a:r>
@@ -2084,7 +2086,7 @@
           </a:bodyPr>
           <a:lstStyle/>
           <a:p>
-            <a:pPr indent="0" marL="0">
+            <a:pPr marL="0" indent="0">
               <a:buNone/>
             </a:pPr>
             <a:r>
@@ -2126,6 +2128,13 @@
             <a:prstDash val="solid"/>
           </a:ln>
         </p:spPr>
+        <p:txBody>
+          <a:bodyPr/>
+          <a:lstStyle/>
+          <a:p>
+            <a:endParaRPr lang="es-MX"/>
+          </a:p>
+        </p:txBody>
       </p:sp>
       <p:sp>
         <p:nvSpPr>
@@ -2150,7 +2159,7 @@
           </a:bodyPr>
           <a:lstStyle/>
           <a:p>
-            <a:pPr indent="0" marL="0">
+            <a:pPr marL="0" indent="0">
               <a:buNone/>
             </a:pPr>
             <a:r>
@@ -2192,6 +2201,13 @@
             <a:prstDash val="solid"/>
           </a:ln>
         </p:spPr>
+        <p:txBody>
+          <a:bodyPr/>
+          <a:lstStyle/>
+          <a:p>
+            <a:endParaRPr lang="es-MX"/>
+          </a:p>
+        </p:txBody>
       </p:sp>
       <p:sp>
         <p:nvSpPr>
@@ -2216,7 +2232,7 @@
           </a:bodyPr>
           <a:lstStyle/>
           <a:p>
-            <a:pPr indent="0" marL="0">
+            <a:pPr marL="0" indent="0">
               <a:buNone/>
             </a:pPr>
             <a:r>
@@ -2258,6 +2274,13 @@
             <a:prstDash val="solid"/>
           </a:ln>
         </p:spPr>
+        <p:txBody>
+          <a:bodyPr/>
+          <a:lstStyle/>
+          <a:p>
+            <a:endParaRPr lang="es-MX"/>
+          </a:p>
+        </p:txBody>
       </p:sp>
       <p:sp>
         <p:nvSpPr>
@@ -2282,7 +2305,7 @@
           </a:bodyPr>
           <a:lstStyle/>
           <a:p>
-            <a:pPr indent="0" marL="0">
+            <a:pPr marL="0" indent="0">
               <a:buNone/>
             </a:pPr>
             <a:r>
@@ -2324,6 +2347,13 @@
             <a:prstDash val="solid"/>
           </a:ln>
         </p:spPr>
+        <p:txBody>
+          <a:bodyPr/>
+          <a:lstStyle/>
+          <a:p>
+            <a:endParaRPr lang="es-MX"/>
+          </a:p>
+        </p:txBody>
       </p:sp>
       <p:sp>
         <p:nvSpPr>
@@ -2348,7 +2378,7 @@
           </a:bodyPr>
           <a:lstStyle/>
           <a:p>
-            <a:pPr indent="0" marL="0">
+            <a:pPr marL="0" indent="0">
               <a:buNone/>
             </a:pPr>
             <a:r>
@@ -2390,6 +2420,13 @@
             <a:prstDash val="solid"/>
           </a:ln>
         </p:spPr>
+        <p:txBody>
+          <a:bodyPr/>
+          <a:lstStyle/>
+          <a:p>
+            <a:endParaRPr lang="es-MX"/>
+          </a:p>
+        </p:txBody>
       </p:sp>
       <p:sp>
         <p:nvSpPr>
@@ -2414,7 +2451,7 @@
           </a:bodyPr>
           <a:lstStyle/>
           <a:p>
-            <a:pPr indent="0" marL="0">
+            <a:pPr marL="0" indent="0">
               <a:buNone/>
             </a:pPr>
             <a:r>
@@ -2456,6 +2493,13 @@
             <a:prstDash val="solid"/>
           </a:ln>
         </p:spPr>
+        <p:txBody>
+          <a:bodyPr/>
+          <a:lstStyle/>
+          <a:p>
+            <a:endParaRPr lang="es-MX"/>
+          </a:p>
+        </p:txBody>
       </p:sp>
       <p:sp>
         <p:nvSpPr>
@@ -2483,13 +2527,20 @@
             <a:prstDash val="solid"/>
           </a:ln>
           <a:effectLst>
-            <a:outerShdw sx="100000" sy="100000" kx="0" ky="0" algn="bl" rotWithShape="0" blurRad="12700" dist="50800" dir="2700000">
+            <a:outerShdw blurRad="12700" dist="50800" dir="2700000" algn="bl" rotWithShape="0">
               <a:srgbClr val="B8C5CF">
                 <a:alpha val="14000"/>
               </a:srgbClr>
             </a:outerShdw>
           </a:effectLst>
         </p:spPr>
+        <p:txBody>
+          <a:bodyPr/>
+          <a:lstStyle/>
+          <a:p>
+            <a:endParaRPr lang="es-MX"/>
+          </a:p>
+        </p:txBody>
       </p:sp>
       <p:sp>
         <p:nvSpPr>
@@ -2517,6 +2568,13 @@
             <a:prstDash val="solid"/>
           </a:ln>
         </p:spPr>
+        <p:txBody>
+          <a:bodyPr/>
+          <a:lstStyle/>
+          <a:p>
+            <a:endParaRPr lang="es-MX"/>
+          </a:p>
+        </p:txBody>
       </p:sp>
       <p:sp>
         <p:nvSpPr>
@@ -2541,7 +2599,7 @@
           </a:bodyPr>
           <a:lstStyle/>
           <a:p>
-            <a:pPr algn="ctr" indent="0" marL="0">
+            <a:pPr marL="0" indent="0" algn="ctr">
               <a:buNone/>
             </a:pPr>
             <a:r>
@@ -2582,7 +2640,7 @@
           </a:bodyPr>
           <a:lstStyle/>
           <a:p>
-            <a:pPr indent="0" marL="0">
+            <a:pPr marL="0" indent="0">
               <a:buNone/>
             </a:pPr>
             <a:r>
@@ -2623,7 +2681,7 @@
           </a:bodyPr>
           <a:lstStyle/>
           <a:p>
-            <a:pPr indent="0" marL="0">
+            <a:pPr marL="0" indent="0">
               <a:buNone/>
             </a:pPr>
             <a:r>
@@ -2665,6 +2723,13 @@
             <a:prstDash val="solid"/>
           </a:ln>
         </p:spPr>
+        <p:txBody>
+          <a:bodyPr/>
+          <a:lstStyle/>
+          <a:p>
+            <a:endParaRPr lang="es-MX"/>
+          </a:p>
+        </p:txBody>
       </p:sp>
       <p:sp>
         <p:nvSpPr>
@@ -2689,7 +2754,7 @@
           </a:bodyPr>
           <a:lstStyle/>
           <a:p>
-            <a:pPr indent="0" marL="0">
+            <a:pPr marL="0" indent="0">
               <a:buNone/>
             </a:pPr>
             <a:r>
@@ -2731,6 +2796,13 @@
             <a:prstDash val="solid"/>
           </a:ln>
         </p:spPr>
+        <p:txBody>
+          <a:bodyPr/>
+          <a:lstStyle/>
+          <a:p>
+            <a:endParaRPr lang="es-MX"/>
+          </a:p>
+        </p:txBody>
       </p:sp>
       <p:sp>
         <p:nvSpPr>
@@ -2755,7 +2827,7 @@
           </a:bodyPr>
           <a:lstStyle/>
           <a:p>
-            <a:pPr indent="0" marL="0">
+            <a:pPr marL="0" indent="0">
               <a:buNone/>
             </a:pPr>
             <a:r>
@@ -2797,6 +2869,13 @@
             <a:prstDash val="solid"/>
           </a:ln>
         </p:spPr>
+        <p:txBody>
+          <a:bodyPr/>
+          <a:lstStyle/>
+          <a:p>
+            <a:endParaRPr lang="es-MX"/>
+          </a:p>
+        </p:txBody>
       </p:sp>
       <p:sp>
         <p:nvSpPr>
@@ -2821,7 +2900,7 @@
           </a:bodyPr>
           <a:lstStyle/>
           <a:p>
-            <a:pPr indent="0" marL="0">
+            <a:pPr marL="0" indent="0">
               <a:buNone/>
             </a:pPr>
             <a:r>
@@ -2863,6 +2942,13 @@
             <a:prstDash val="solid"/>
           </a:ln>
         </p:spPr>
+        <p:txBody>
+          <a:bodyPr/>
+          <a:lstStyle/>
+          <a:p>
+            <a:endParaRPr lang="es-MX"/>
+          </a:p>
+        </p:txBody>
       </p:sp>
       <p:sp>
         <p:nvSpPr>
@@ -2887,7 +2973,7 @@
           </a:bodyPr>
           <a:lstStyle/>
           <a:p>
-            <a:pPr indent="0" marL="0">
+            <a:pPr marL="0" indent="0">
               <a:buNone/>
             </a:pPr>
             <a:r>
@@ -2929,6 +3015,13 @@
             <a:prstDash val="solid"/>
           </a:ln>
         </p:spPr>
+        <p:txBody>
+          <a:bodyPr/>
+          <a:lstStyle/>
+          <a:p>
+            <a:endParaRPr lang="es-MX"/>
+          </a:p>
+        </p:txBody>
       </p:sp>
       <p:sp>
         <p:nvSpPr>
@@ -2953,7 +3046,7 @@
           </a:bodyPr>
           <a:lstStyle/>
           <a:p>
-            <a:pPr indent="0" marL="0">
+            <a:pPr marL="0" indent="0">
               <a:buNone/>
             </a:pPr>
             <a:r>
@@ -2995,6 +3088,13 @@
             <a:prstDash val="solid"/>
           </a:ln>
         </p:spPr>
+        <p:txBody>
+          <a:bodyPr/>
+          <a:lstStyle/>
+          <a:p>
+            <a:endParaRPr lang="es-MX"/>
+          </a:p>
+        </p:txBody>
       </p:sp>
       <p:sp>
         <p:nvSpPr>
@@ -3022,13 +3122,20 @@
             <a:prstDash val="solid"/>
           </a:ln>
           <a:effectLst>
-            <a:outerShdw sx="100000" sy="100000" kx="0" ky="0" algn="bl" rotWithShape="0" blurRad="12700" dist="50800" dir="2700000">
+            <a:outerShdw blurRad="12700" dist="50800" dir="2700000" algn="bl" rotWithShape="0">
               <a:srgbClr val="B8C5CF">
                 <a:alpha val="14000"/>
               </a:srgbClr>
             </a:outerShdw>
           </a:effectLst>
         </p:spPr>
+        <p:txBody>
+          <a:bodyPr/>
+          <a:lstStyle/>
+          <a:p>
+            <a:endParaRPr lang="es-MX"/>
+          </a:p>
+        </p:txBody>
       </p:sp>
       <p:sp>
         <p:nvSpPr>
@@ -3056,6 +3163,13 @@
             <a:prstDash val="solid"/>
           </a:ln>
         </p:spPr>
+        <p:txBody>
+          <a:bodyPr/>
+          <a:lstStyle/>
+          <a:p>
+            <a:endParaRPr lang="es-MX"/>
+          </a:p>
+        </p:txBody>
       </p:sp>
       <p:sp>
         <p:nvSpPr>
@@ -3080,7 +3194,7 @@
           </a:bodyPr>
           <a:lstStyle/>
           <a:p>
-            <a:pPr algn="ctr" indent="0" marL="0">
+            <a:pPr marL="0" indent="0" algn="ctr">
               <a:buNone/>
             </a:pPr>
             <a:r>
@@ -3121,7 +3235,7 @@
           </a:bodyPr>
           <a:lstStyle/>
           <a:p>
-            <a:pPr indent="0" marL="0">
+            <a:pPr marL="0" indent="0">
               <a:buNone/>
             </a:pPr>
             <a:r>
@@ -3162,7 +3276,7 @@
           </a:bodyPr>
           <a:lstStyle/>
           <a:p>
-            <a:pPr indent="0" marL="0">
+            <a:pPr marL="0" indent="0">
               <a:buNone/>
             </a:pPr>
             <a:r>
@@ -3204,6 +3318,13 @@
             <a:prstDash val="solid"/>
           </a:ln>
         </p:spPr>
+        <p:txBody>
+          <a:bodyPr/>
+          <a:lstStyle/>
+          <a:p>
+            <a:endParaRPr lang="es-MX"/>
+          </a:p>
+        </p:txBody>
       </p:sp>
       <p:sp>
         <p:nvSpPr>
@@ -3228,7 +3349,7 @@
           </a:bodyPr>
           <a:lstStyle/>
           <a:p>
-            <a:pPr indent="0" marL="0">
+            <a:pPr marL="0" indent="0">
               <a:buNone/>
             </a:pPr>
             <a:r>
@@ -3270,6 +3391,13 @@
             <a:prstDash val="solid"/>
           </a:ln>
         </p:spPr>
+        <p:txBody>
+          <a:bodyPr/>
+          <a:lstStyle/>
+          <a:p>
+            <a:endParaRPr lang="es-MX"/>
+          </a:p>
+        </p:txBody>
       </p:sp>
       <p:sp>
         <p:nvSpPr>
@@ -3294,7 +3422,7 @@
           </a:bodyPr>
           <a:lstStyle/>
           <a:p>
-            <a:pPr indent="0" marL="0">
+            <a:pPr marL="0" indent="0">
               <a:buNone/>
             </a:pPr>
             <a:r>
@@ -3336,6 +3464,13 @@
             <a:prstDash val="solid"/>
           </a:ln>
         </p:spPr>
+        <p:txBody>
+          <a:bodyPr/>
+          <a:lstStyle/>
+          <a:p>
+            <a:endParaRPr lang="es-MX"/>
+          </a:p>
+        </p:txBody>
       </p:sp>
       <p:sp>
         <p:nvSpPr>
@@ -3360,7 +3495,7 @@
           </a:bodyPr>
           <a:lstStyle/>
           <a:p>
-            <a:pPr indent="0" marL="0">
+            <a:pPr marL="0" indent="0">
               <a:buNone/>
             </a:pPr>
             <a:r>
@@ -3402,6 +3537,13 @@
             <a:prstDash val="solid"/>
           </a:ln>
         </p:spPr>
+        <p:txBody>
+          <a:bodyPr/>
+          <a:lstStyle/>
+          <a:p>
+            <a:endParaRPr lang="es-MX"/>
+          </a:p>
+        </p:txBody>
       </p:sp>
       <p:sp>
         <p:nvSpPr>
@@ -3426,7 +3568,7 @@
           </a:bodyPr>
           <a:lstStyle/>
           <a:p>
-            <a:pPr indent="0" marL="0">
+            <a:pPr marL="0" indent="0">
               <a:buNone/>
             </a:pPr>
             <a:r>
@@ -3468,6 +3610,13 @@
             <a:prstDash val="solid"/>
           </a:ln>
         </p:spPr>
+        <p:txBody>
+          <a:bodyPr/>
+          <a:lstStyle/>
+          <a:p>
+            <a:endParaRPr lang="es-MX"/>
+          </a:p>
+        </p:txBody>
       </p:sp>
       <p:sp>
         <p:nvSpPr>
@@ -3495,13 +3644,20 @@
             <a:prstDash val="solid"/>
           </a:ln>
           <a:effectLst>
-            <a:outerShdw sx="100000" sy="100000" kx="0" ky="0" algn="bl" rotWithShape="0" blurRad="12700" dist="50800" dir="2700000">
+            <a:outerShdw blurRad="12700" dist="50800" dir="2700000" algn="bl" rotWithShape="0">
               <a:srgbClr val="B8C5CF">
                 <a:alpha val="14000"/>
               </a:srgbClr>
             </a:outerShdw>
           </a:effectLst>
         </p:spPr>
+        <p:txBody>
+          <a:bodyPr/>
+          <a:lstStyle/>
+          <a:p>
+            <a:endParaRPr lang="es-MX"/>
+          </a:p>
+        </p:txBody>
       </p:sp>
       <p:sp>
         <p:nvSpPr>
@@ -3529,6 +3685,13 @@
             <a:prstDash val="solid"/>
           </a:ln>
         </p:spPr>
+        <p:txBody>
+          <a:bodyPr/>
+          <a:lstStyle/>
+          <a:p>
+            <a:endParaRPr lang="es-MX"/>
+          </a:p>
+        </p:txBody>
       </p:sp>
       <p:sp>
         <p:nvSpPr>
@@ -3553,7 +3716,7 @@
           </a:bodyPr>
           <a:lstStyle/>
           <a:p>
-            <a:pPr algn="ctr" indent="0" marL="0">
+            <a:pPr marL="0" indent="0" algn="ctr">
               <a:buNone/>
             </a:pPr>
             <a:r>
@@ -3594,7 +3757,7 @@
           </a:bodyPr>
           <a:lstStyle/>
           <a:p>
-            <a:pPr indent="0" marL="0">
+            <a:pPr marL="0" indent="0">
               <a:buNone/>
             </a:pPr>
             <a:r>
@@ -3635,7 +3798,7 @@
           </a:bodyPr>
           <a:lstStyle/>
           <a:p>
-            <a:pPr indent="0" marL="0">
+            <a:pPr marL="0" indent="0">
               <a:buNone/>
             </a:pPr>
             <a:r>
@@ -3677,6 +3840,13 @@
             <a:prstDash val="solid"/>
           </a:ln>
         </p:spPr>
+        <p:txBody>
+          <a:bodyPr/>
+          <a:lstStyle/>
+          <a:p>
+            <a:endParaRPr lang="es-MX"/>
+          </a:p>
+        </p:txBody>
       </p:sp>
       <p:sp>
         <p:nvSpPr>
@@ -3701,7 +3871,7 @@
           </a:bodyPr>
           <a:lstStyle/>
           <a:p>
-            <a:pPr indent="0" marL="0">
+            <a:pPr marL="0" indent="0">
               <a:buNone/>
             </a:pPr>
             <a:r>
@@ -3743,6 +3913,13 @@
             <a:prstDash val="solid"/>
           </a:ln>
         </p:spPr>
+        <p:txBody>
+          <a:bodyPr/>
+          <a:lstStyle/>
+          <a:p>
+            <a:endParaRPr lang="es-MX"/>
+          </a:p>
+        </p:txBody>
       </p:sp>
       <p:sp>
         <p:nvSpPr>
@@ -3767,7 +3944,7 @@
           </a:bodyPr>
           <a:lstStyle/>
           <a:p>
-            <a:pPr indent="0" marL="0">
+            <a:pPr marL="0" indent="0">
               <a:buNone/>
             </a:pPr>
             <a:r>
@@ -3809,6 +3986,13 @@
             <a:prstDash val="solid"/>
           </a:ln>
         </p:spPr>
+        <p:txBody>
+          <a:bodyPr/>
+          <a:lstStyle/>
+          <a:p>
+            <a:endParaRPr lang="es-MX"/>
+          </a:p>
+        </p:txBody>
       </p:sp>
       <p:sp>
         <p:nvSpPr>
@@ -3833,7 +4017,7 @@
           </a:bodyPr>
           <a:lstStyle/>
           <a:p>
-            <a:pPr indent="0" marL="0">
+            <a:pPr marL="0" indent="0">
               <a:buNone/>
             </a:pPr>
             <a:r>
@@ -3875,6 +4059,13 @@
             <a:prstDash val="solid"/>
           </a:ln>
         </p:spPr>
+        <p:txBody>
+          <a:bodyPr/>
+          <a:lstStyle/>
+          <a:p>
+            <a:endParaRPr lang="es-MX"/>
+          </a:p>
+        </p:txBody>
       </p:sp>
       <p:sp>
         <p:nvSpPr>
@@ -3899,7 +4090,7 @@
           </a:bodyPr>
           <a:lstStyle/>
           <a:p>
-            <a:pPr indent="0" marL="0">
+            <a:pPr marL="0" indent="0">
               <a:buNone/>
             </a:pPr>
             <a:r>
@@ -3941,6 +4132,13 @@
             <a:prstDash val="solid"/>
           </a:ln>
         </p:spPr>
+        <p:txBody>
+          <a:bodyPr/>
+          <a:lstStyle/>
+          <a:p>
+            <a:endParaRPr lang="es-MX"/>
+          </a:p>
+        </p:txBody>
       </p:sp>
       <p:sp>
         <p:nvSpPr>
@@ -3965,7 +4163,7 @@
           </a:bodyPr>
           <a:lstStyle/>
           <a:p>
-            <a:pPr indent="0" marL="0">
+            <a:pPr marL="0" indent="0">
               <a:buNone/>
             </a:pPr>
             <a:r>
@@ -3999,6 +4197,7 @@
         <a:solidFill>
           <a:srgbClr val="FFFFFF"/>
         </a:solidFill>
+        <a:effectLst/>
       </p:bgPr>
     </p:bg>
     <p:spTree>
@@ -4039,6 +4238,13 @@
             <a:prstDash val="solid"/>
           </a:ln>
         </p:spPr>
+        <p:txBody>
+          <a:bodyPr/>
+          <a:lstStyle/>
+          <a:p>
+            <a:endParaRPr lang="es-MX"/>
+          </a:p>
+        </p:txBody>
       </p:sp>
       <p:sp>
         <p:nvSpPr>
@@ -4061,11 +4267,11 @@
           <a:bodyPr wrap="square" lIns="0" tIns="0" rIns="0" bIns="0" rtlCol="0" anchor="ctr"/>
           <a:lstStyle/>
           <a:p>
-            <a:pPr indent="0" marL="0">
-              <a:buNone/>
-            </a:pPr>
-            <a:r>
-              <a:rPr lang="en-US" sz="900" b="1" spc="120" kern="0" dirty="0">
+            <a:pPr marL="0" indent="0">
+              <a:buNone/>
+            </a:pPr>
+            <a:r>
+              <a:rPr lang="en-US" sz="900" b="1" kern="0" spc="120" dirty="0">
                 <a:solidFill>
                   <a:srgbClr val="5B8296"/>
                 </a:solidFill>
@@ -4100,7 +4306,7 @@
           <a:bodyPr wrap="square" lIns="0" tIns="0" rIns="0" bIns="0" rtlCol="0" anchor="ctr"/>
           <a:lstStyle/>
           <a:p>
-            <a:pPr indent="0" marL="0">
+            <a:pPr marL="0" indent="0">
               <a:buNone/>
             </a:pPr>
             <a:r>
@@ -4120,14 +4326,14 @@
       </p:sp>
       <p:pic>
         <p:nvPicPr>
-          <p:cNvPr id="5" name="Image 0" descr="/mnt/data/work_jama/ppt/media/image1.png">    </p:cNvPr>
+          <p:cNvPr id="5" name="Image 0" descr="/mnt/data/work_jama/ppt/media/image1.png"/>
           <p:cNvPicPr>
             <a:picLocks noChangeAspect="1"/>
           </p:cNvPicPr>
           <p:nvPr/>
         </p:nvPicPr>
         <p:blipFill>
-          <a:blip r:embed="rId1"/>
+          <a:blip r:embed="rId3"/>
           <a:stretch>
             <a:fillRect/>
           </a:stretch>
@@ -4163,7 +4369,7 @@
           <a:bodyPr wrap="square" lIns="0" tIns="0" rIns="0" bIns="0" rtlCol="0" anchor="ctr"/>
           <a:lstStyle/>
           <a:p>
-            <a:pPr algn="r" indent="0" marL="0">
+            <a:pPr marL="0" indent="0" algn="r">
               <a:buNone/>
             </a:pPr>
             <a:r>
@@ -4200,6 +4406,13 @@
             <a:prstDash val="solid"/>
           </a:ln>
         </p:spPr>
+        <p:txBody>
+          <a:bodyPr/>
+          <a:lstStyle/>
+          <a:p>
+            <a:endParaRPr lang="es-MX"/>
+          </a:p>
+        </p:txBody>
       </p:sp>
       <p:sp>
         <p:nvSpPr>
@@ -4227,6 +4440,13 @@
             <a:prstDash val="solid"/>
           </a:ln>
         </p:spPr>
+        <p:txBody>
+          <a:bodyPr/>
+          <a:lstStyle/>
+          <a:p>
+            <a:endParaRPr lang="es-MX"/>
+          </a:p>
+        </p:txBody>
       </p:sp>
       <p:sp>
         <p:nvSpPr>
@@ -4251,7 +4471,7 @@
           </a:bodyPr>
           <a:lstStyle/>
           <a:p>
-            <a:pPr algn="ctr" indent="0" marL="0">
+            <a:pPr marL="0" indent="0" algn="ctr">
               <a:buNone/>
             </a:pPr>
             <a:r>
@@ -4292,7 +4512,7 @@
           </a:bodyPr>
           <a:lstStyle/>
           <a:p>
-            <a:pPr algn="ctr" indent="0" marL="0">
+            <a:pPr marL="0" indent="0" algn="ctr">
               <a:buNone/>
             </a:pPr>
             <a:r>
@@ -4309,7 +4529,7 @@
             <a:endParaRPr lang="en-US" sz="1000" dirty="0"/>
           </a:p>
           <a:p>
-            <a:pPr algn="ctr" indent="0" marL="0">
+            <a:pPr marL="0" indent="0" algn="ctr">
               <a:buNone/>
             </a:pPr>
             <a:r>
@@ -4351,6 +4571,13 @@
             <a:prstDash val="solid"/>
           </a:ln>
         </p:spPr>
+        <p:txBody>
+          <a:bodyPr/>
+          <a:lstStyle/>
+          <a:p>
+            <a:endParaRPr lang="es-MX"/>
+          </a:p>
+        </p:txBody>
       </p:sp>
       <p:sp>
         <p:nvSpPr>
@@ -4378,6 +4605,13 @@
             <a:prstDash val="solid"/>
           </a:ln>
         </p:spPr>
+        <p:txBody>
+          <a:bodyPr/>
+          <a:lstStyle/>
+          <a:p>
+            <a:endParaRPr lang="es-MX"/>
+          </a:p>
+        </p:txBody>
       </p:sp>
       <p:sp>
         <p:nvSpPr>
@@ -4402,7 +4636,7 @@
           </a:bodyPr>
           <a:lstStyle/>
           <a:p>
-            <a:pPr algn="ctr" indent="0" marL="0">
+            <a:pPr marL="0" indent="0" algn="ctr">
               <a:buNone/>
             </a:pPr>
             <a:r>
@@ -4443,7 +4677,7 @@
           </a:bodyPr>
           <a:lstStyle/>
           <a:p>
-            <a:pPr algn="ctr" indent="0" marL="0">
+            <a:pPr marL="0" indent="0" algn="ctr">
               <a:buNone/>
             </a:pPr>
             <a:r>
@@ -4485,6 +4719,13 @@
             <a:prstDash val="solid"/>
           </a:ln>
         </p:spPr>
+        <p:txBody>
+          <a:bodyPr/>
+          <a:lstStyle/>
+          <a:p>
+            <a:endParaRPr lang="es-MX"/>
+          </a:p>
+        </p:txBody>
       </p:sp>
       <p:sp>
         <p:nvSpPr>
@@ -4512,6 +4753,13 @@
             <a:prstDash val="solid"/>
           </a:ln>
         </p:spPr>
+        <p:txBody>
+          <a:bodyPr/>
+          <a:lstStyle/>
+          <a:p>
+            <a:endParaRPr lang="es-MX"/>
+          </a:p>
+        </p:txBody>
       </p:sp>
       <p:sp>
         <p:nvSpPr>
@@ -4536,7 +4784,7 @@
           </a:bodyPr>
           <a:lstStyle/>
           <a:p>
-            <a:pPr algn="ctr" indent="0" marL="0">
+            <a:pPr marL="0" indent="0" algn="ctr">
               <a:buNone/>
             </a:pPr>
             <a:r>
@@ -4577,7 +4825,7 @@
           </a:bodyPr>
           <a:lstStyle/>
           <a:p>
-            <a:pPr algn="ctr" indent="0" marL="0">
+            <a:pPr marL="0" indent="0" algn="ctr">
               <a:buNone/>
             </a:pPr>
             <a:r>
@@ -4594,7 +4842,7 @@
             <a:endParaRPr lang="en-US" sz="1000" dirty="0"/>
           </a:p>
           <a:p>
-            <a:pPr algn="ctr" indent="0" marL="0">
+            <a:pPr marL="0" indent="0" algn="ctr">
               <a:buNone/>
             </a:pPr>
             <a:r>
@@ -4636,6 +4884,13 @@
             <a:prstDash val="solid"/>
           </a:ln>
         </p:spPr>
+        <p:txBody>
+          <a:bodyPr/>
+          <a:lstStyle/>
+          <a:p>
+            <a:endParaRPr lang="es-MX"/>
+          </a:p>
+        </p:txBody>
       </p:sp>
       <p:sp>
         <p:nvSpPr>
@@ -4663,6 +4918,13 @@
             <a:prstDash val="solid"/>
           </a:ln>
         </p:spPr>
+        <p:txBody>
+          <a:bodyPr/>
+          <a:lstStyle/>
+          <a:p>
+            <a:endParaRPr lang="es-MX"/>
+          </a:p>
+        </p:txBody>
       </p:sp>
       <p:sp>
         <p:nvSpPr>
@@ -4687,7 +4949,7 @@
           </a:bodyPr>
           <a:lstStyle/>
           <a:p>
-            <a:pPr algn="ctr" indent="0" marL="0">
+            <a:pPr marL="0" indent="0" algn="ctr">
               <a:buNone/>
             </a:pPr>
             <a:r>
@@ -4728,7 +4990,7 @@
           </a:bodyPr>
           <a:lstStyle/>
           <a:p>
-            <a:pPr algn="ctr" indent="0" marL="0">
+            <a:pPr marL="0" indent="0" algn="ctr">
               <a:buNone/>
             </a:pPr>
             <a:r>
@@ -4745,7 +5007,7 @@
             <a:endParaRPr lang="en-US" sz="1000" dirty="0"/>
           </a:p>
           <a:p>
-            <a:pPr algn="ctr" indent="0" marL="0">
+            <a:pPr marL="0" indent="0" algn="ctr">
               <a:buNone/>
             </a:pPr>
             <a:r>
@@ -4787,6 +5049,13 @@
             <a:prstDash val="solid"/>
           </a:ln>
         </p:spPr>
+        <p:txBody>
+          <a:bodyPr/>
+          <a:lstStyle/>
+          <a:p>
+            <a:endParaRPr lang="es-MX"/>
+          </a:p>
+        </p:txBody>
       </p:sp>
       <p:sp>
         <p:nvSpPr>
@@ -4814,6 +5083,13 @@
             <a:prstDash val="solid"/>
           </a:ln>
         </p:spPr>
+        <p:txBody>
+          <a:bodyPr/>
+          <a:lstStyle/>
+          <a:p>
+            <a:endParaRPr lang="es-MX"/>
+          </a:p>
+        </p:txBody>
       </p:sp>
       <p:sp>
         <p:nvSpPr>
@@ -4838,7 +5114,7 @@
           </a:bodyPr>
           <a:lstStyle/>
           <a:p>
-            <a:pPr algn="ctr" indent="0" marL="0">
+            <a:pPr marL="0" indent="0" algn="ctr">
               <a:buNone/>
             </a:pPr>
             <a:r>
@@ -4879,7 +5155,7 @@
           </a:bodyPr>
           <a:lstStyle/>
           <a:p>
-            <a:pPr algn="ctr" indent="0" marL="0">
+            <a:pPr marL="0" indent="0" algn="ctr">
               <a:buNone/>
             </a:pPr>
             <a:r>
@@ -4921,6 +5197,13 @@
             <a:tailEnd type="triangle"/>
           </a:ln>
         </p:spPr>
+        <p:txBody>
+          <a:bodyPr/>
+          <a:lstStyle/>
+          <a:p>
+            <a:endParaRPr lang="es-MX"/>
+          </a:p>
+        </p:txBody>
       </p:sp>
       <p:sp>
         <p:nvSpPr>
@@ -4948,6 +5231,13 @@
             <a:prstDash val="solid"/>
           </a:ln>
         </p:spPr>
+        <p:txBody>
+          <a:bodyPr/>
+          <a:lstStyle/>
+          <a:p>
+            <a:endParaRPr lang="es-MX"/>
+          </a:p>
+        </p:txBody>
       </p:sp>
       <p:sp>
         <p:nvSpPr>
@@ -4972,7 +5262,7 @@
           </a:bodyPr>
           <a:lstStyle/>
           <a:p>
-            <a:pPr algn="ctr" indent="0" marL="0">
+            <a:pPr marL="0" indent="0" algn="ctr">
               <a:buNone/>
             </a:pPr>
             <a:r>
@@ -5013,7 +5303,7 @@
           </a:bodyPr>
           <a:lstStyle/>
           <a:p>
-            <a:pPr algn="ctr" indent="0" marL="0">
+            <a:pPr marL="0" indent="0" algn="ctr">
               <a:buNone/>
             </a:pPr>
             <a:r>
@@ -5057,6 +5347,13 @@
             <a:prstDash val="solid"/>
           </a:ln>
         </p:spPr>
+        <p:txBody>
+          <a:bodyPr/>
+          <a:lstStyle/>
+          <a:p>
+            <a:endParaRPr lang="es-MX"/>
+          </a:p>
+        </p:txBody>
       </p:sp>
       <p:sp>
         <p:nvSpPr>
@@ -5084,6 +5381,13 @@
             <a:prstDash val="solid"/>
           </a:ln>
         </p:spPr>
+        <p:txBody>
+          <a:bodyPr/>
+          <a:lstStyle/>
+          <a:p>
+            <a:endParaRPr lang="es-MX"/>
+          </a:p>
+        </p:txBody>
       </p:sp>
       <p:sp>
         <p:nvSpPr>
@@ -5108,7 +5412,7 @@
           </a:bodyPr>
           <a:lstStyle/>
           <a:p>
-            <a:pPr algn="ctr" indent="0" marL="0">
+            <a:pPr marL="0" indent="0" algn="ctr">
               <a:buNone/>
             </a:pPr>
             <a:r>
@@ -5149,7 +5453,7 @@
           </a:bodyPr>
           <a:lstStyle/>
           <a:p>
-            <a:pPr indent="0" marL="0">
+            <a:pPr marL="0" indent="0">
               <a:buNone/>
             </a:pPr>
             <a:r>
@@ -5183,6 +5487,7 @@
         <a:solidFill>
           <a:srgbClr val="FFFFFF"/>
         </a:solidFill>
+        <a:effectLst/>
       </p:bgPr>
     </p:bg>
     <p:spTree>
@@ -5223,6 +5528,13 @@
             <a:prstDash val="solid"/>
           </a:ln>
         </p:spPr>
+        <p:txBody>
+          <a:bodyPr/>
+          <a:lstStyle/>
+          <a:p>
+            <a:endParaRPr lang="es-MX"/>
+          </a:p>
+        </p:txBody>
       </p:sp>
       <p:sp>
         <p:nvSpPr>
@@ -5245,11 +5557,11 @@
           <a:bodyPr wrap="square" lIns="0" tIns="0" rIns="0" bIns="0" rtlCol="0" anchor="ctr"/>
           <a:lstStyle/>
           <a:p>
-            <a:pPr indent="0" marL="0">
-              <a:buNone/>
-            </a:pPr>
-            <a:r>
-              <a:rPr lang="en-US" sz="900" b="1" spc="120" kern="0" dirty="0">
+            <a:pPr marL="0" indent="0">
+              <a:buNone/>
+            </a:pPr>
+            <a:r>
+              <a:rPr lang="en-US" sz="900" b="1" kern="0" spc="120" dirty="0">
                 <a:solidFill>
                   <a:srgbClr val="5B8296"/>
                 </a:solidFill>
@@ -5284,7 +5596,7 @@
           <a:bodyPr wrap="square" lIns="0" tIns="0" rIns="0" bIns="0" rtlCol="0" anchor="ctr"/>
           <a:lstStyle/>
           <a:p>
-            <a:pPr indent="0" marL="0">
+            <a:pPr marL="0" indent="0">
               <a:buNone/>
             </a:pPr>
             <a:r>
@@ -5304,14 +5616,14 @@
       </p:sp>
       <p:pic>
         <p:nvPicPr>
-          <p:cNvPr id="5" name="Image 0" descr="/mnt/data/work_jama/ppt/media/image1.png">    </p:cNvPr>
+          <p:cNvPr id="5" name="Image 0" descr="/mnt/data/work_jama/ppt/media/image1.png"/>
           <p:cNvPicPr>
             <a:picLocks noChangeAspect="1"/>
           </p:cNvPicPr>
           <p:nvPr/>
         </p:nvPicPr>
         <p:blipFill>
-          <a:blip r:embed="rId1"/>
+          <a:blip r:embed="rId3"/>
           <a:stretch>
             <a:fillRect/>
           </a:stretch>
@@ -5347,7 +5659,7 @@
           <a:bodyPr wrap="square" lIns="0" tIns="0" rIns="0" bIns="0" rtlCol="0" anchor="ctr"/>
           <a:lstStyle/>
           <a:p>
-            <a:pPr algn="r" indent="0" marL="0">
+            <a:pPr marL="0" indent="0" algn="r">
               <a:buNone/>
             </a:pPr>
             <a:r>
@@ -5384,6 +5696,13 @@
             <a:prstDash val="solid"/>
           </a:ln>
         </p:spPr>
+        <p:txBody>
+          <a:bodyPr/>
+          <a:lstStyle/>
+          <a:p>
+            <a:endParaRPr lang="es-MX"/>
+          </a:p>
+        </p:txBody>
       </p:sp>
       <p:sp>
         <p:nvSpPr>
@@ -5409,6 +5728,13 @@
             <a:prstDash val="solid"/>
           </a:ln>
         </p:spPr>
+        <p:txBody>
+          <a:bodyPr/>
+          <a:lstStyle/>
+          <a:p>
+            <a:endParaRPr lang="es-MX"/>
+          </a:p>
+        </p:txBody>
       </p:sp>
       <p:sp>
         <p:nvSpPr>
@@ -5433,7 +5759,7 @@
           </a:bodyPr>
           <a:lstStyle/>
           <a:p>
-            <a:pPr algn="ctr" indent="0" marL="0">
+            <a:pPr marL="0" indent="0" algn="ctr">
               <a:buNone/>
             </a:pPr>
             <a:endParaRPr lang="en-US" sz="900" dirty="0"/>
@@ -5464,6 +5790,13 @@
             <a:prstDash val="solid"/>
           </a:ln>
         </p:spPr>
+        <p:txBody>
+          <a:bodyPr/>
+          <a:lstStyle/>
+          <a:p>
+            <a:endParaRPr lang="es-MX"/>
+          </a:p>
+        </p:txBody>
       </p:sp>
       <p:sp>
         <p:nvSpPr>
@@ -5488,7 +5821,7 @@
           </a:bodyPr>
           <a:lstStyle/>
           <a:p>
-            <a:pPr algn="l" indent="0" marL="0">
+            <a:pPr marL="0" indent="0" algn="l">
               <a:buNone/>
             </a:pPr>
             <a:r>
@@ -5530,6 +5863,13 @@
             <a:prstDash val="solid"/>
           </a:ln>
         </p:spPr>
+        <p:txBody>
+          <a:bodyPr/>
+          <a:lstStyle/>
+          <a:p>
+            <a:endParaRPr lang="es-MX"/>
+          </a:p>
+        </p:txBody>
       </p:sp>
       <p:sp>
         <p:nvSpPr>
@@ -5554,7 +5894,7 @@
           </a:bodyPr>
           <a:lstStyle/>
           <a:p>
-            <a:pPr algn="l" indent="0" marL="0">
+            <a:pPr marL="0" indent="0" algn="l">
               <a:buNone/>
             </a:pPr>
             <a:r>
@@ -5596,6 +5936,13 @@
             <a:prstDash val="solid"/>
           </a:ln>
         </p:spPr>
+        <p:txBody>
+          <a:bodyPr/>
+          <a:lstStyle/>
+          <a:p>
+            <a:endParaRPr lang="es-MX"/>
+          </a:p>
+        </p:txBody>
       </p:sp>
       <p:sp>
         <p:nvSpPr>
@@ -5620,7 +5967,7 @@
           </a:bodyPr>
           <a:lstStyle/>
           <a:p>
-            <a:pPr algn="l" indent="0" marL="0">
+            <a:pPr marL="0" indent="0" algn="l">
               <a:buNone/>
             </a:pPr>
             <a:r>
@@ -5662,6 +6009,13 @@
             <a:prstDash val="solid"/>
           </a:ln>
         </p:spPr>
+        <p:txBody>
+          <a:bodyPr/>
+          <a:lstStyle/>
+          <a:p>
+            <a:endParaRPr lang="es-MX"/>
+          </a:p>
+        </p:txBody>
       </p:sp>
       <p:sp>
         <p:nvSpPr>
@@ -5686,7 +6040,7 @@
           </a:bodyPr>
           <a:lstStyle/>
           <a:p>
-            <a:pPr algn="l" indent="0" marL="0">
+            <a:pPr marL="0" indent="0" algn="l">
               <a:buNone/>
             </a:pPr>
             <a:r>
@@ -5728,6 +6082,13 @@
             <a:prstDash val="solid"/>
           </a:ln>
         </p:spPr>
+        <p:txBody>
+          <a:bodyPr/>
+          <a:lstStyle/>
+          <a:p>
+            <a:endParaRPr lang="es-MX"/>
+          </a:p>
+        </p:txBody>
       </p:sp>
       <p:sp>
         <p:nvSpPr>
@@ -5752,7 +6113,7 @@
           </a:bodyPr>
           <a:lstStyle/>
           <a:p>
-            <a:pPr algn="l" indent="0" marL="0">
+            <a:pPr marL="0" indent="0" algn="l">
               <a:buNone/>
             </a:pPr>
             <a:r>
@@ -5794,6 +6155,13 @@
             <a:prstDash val="solid"/>
           </a:ln>
         </p:spPr>
+        <p:txBody>
+          <a:bodyPr/>
+          <a:lstStyle/>
+          <a:p>
+            <a:endParaRPr lang="es-MX"/>
+          </a:p>
+        </p:txBody>
       </p:sp>
       <p:sp>
         <p:nvSpPr>
@@ -5818,7 +6186,7 @@
           </a:bodyPr>
           <a:lstStyle/>
           <a:p>
-            <a:pPr algn="ctr" indent="0" marL="0">
+            <a:pPr marL="0" indent="0" algn="ctr">
               <a:buNone/>
             </a:pPr>
             <a:r>
@@ -5860,6 +6228,13 @@
             <a:prstDash val="solid"/>
           </a:ln>
         </p:spPr>
+        <p:txBody>
+          <a:bodyPr/>
+          <a:lstStyle/>
+          <a:p>
+            <a:endParaRPr lang="es-MX"/>
+          </a:p>
+        </p:txBody>
       </p:sp>
       <p:sp>
         <p:nvSpPr>
@@ -5884,7 +6259,7 @@
           </a:bodyPr>
           <a:lstStyle/>
           <a:p>
-            <a:pPr algn="l" indent="0" marL="0">
+            <a:pPr marL="0" indent="0" algn="l">
               <a:buNone/>
             </a:pPr>
             <a:r>
@@ -5926,6 +6301,13 @@
             <a:prstDash val="solid"/>
           </a:ln>
         </p:spPr>
+        <p:txBody>
+          <a:bodyPr/>
+          <a:lstStyle/>
+          <a:p>
+            <a:endParaRPr lang="es-MX"/>
+          </a:p>
+        </p:txBody>
       </p:sp>
       <p:sp>
         <p:nvSpPr>
@@ -5950,7 +6332,7 @@
           </a:bodyPr>
           <a:lstStyle/>
           <a:p>
-            <a:pPr algn="l" indent="0" marL="0">
+            <a:pPr marL="0" indent="0" algn="l">
               <a:buNone/>
             </a:pPr>
             <a:r>
@@ -5992,6 +6374,13 @@
             <a:prstDash val="solid"/>
           </a:ln>
         </p:spPr>
+        <p:txBody>
+          <a:bodyPr/>
+          <a:lstStyle/>
+          <a:p>
+            <a:endParaRPr lang="es-MX"/>
+          </a:p>
+        </p:txBody>
       </p:sp>
       <p:sp>
         <p:nvSpPr>
@@ -6016,7 +6405,7 @@
           </a:bodyPr>
           <a:lstStyle/>
           <a:p>
-            <a:pPr algn="l" indent="0" marL="0">
+            <a:pPr marL="0" indent="0" algn="l">
               <a:buNone/>
             </a:pPr>
             <a:r>
@@ -6058,6 +6447,13 @@
             <a:prstDash val="solid"/>
           </a:ln>
         </p:spPr>
+        <p:txBody>
+          <a:bodyPr/>
+          <a:lstStyle/>
+          <a:p>
+            <a:endParaRPr lang="es-MX"/>
+          </a:p>
+        </p:txBody>
       </p:sp>
       <p:sp>
         <p:nvSpPr>
@@ -6082,7 +6478,7 @@
           </a:bodyPr>
           <a:lstStyle/>
           <a:p>
-            <a:pPr algn="l" indent="0" marL="0">
+            <a:pPr marL="0" indent="0" algn="l">
               <a:buNone/>
             </a:pPr>
             <a:r>
@@ -6124,6 +6520,13 @@
             <a:prstDash val="solid"/>
           </a:ln>
         </p:spPr>
+        <p:txBody>
+          <a:bodyPr/>
+          <a:lstStyle/>
+          <a:p>
+            <a:endParaRPr lang="es-MX"/>
+          </a:p>
+        </p:txBody>
       </p:sp>
       <p:sp>
         <p:nvSpPr>
@@ -6148,7 +6551,7 @@
           </a:bodyPr>
           <a:lstStyle/>
           <a:p>
-            <a:pPr algn="l" indent="0" marL="0">
+            <a:pPr marL="0" indent="0" algn="l">
               <a:buNone/>
             </a:pPr>
             <a:r>
@@ -6190,6 +6593,13 @@
             <a:prstDash val="solid"/>
           </a:ln>
         </p:spPr>
+        <p:txBody>
+          <a:bodyPr/>
+          <a:lstStyle/>
+          <a:p>
+            <a:endParaRPr lang="es-MX"/>
+          </a:p>
+        </p:txBody>
       </p:sp>
       <p:sp>
         <p:nvSpPr>
@@ -6214,7 +6624,7 @@
           </a:bodyPr>
           <a:lstStyle/>
           <a:p>
-            <a:pPr algn="ctr" indent="0" marL="0">
+            <a:pPr marL="0" indent="0" algn="ctr">
               <a:buNone/>
             </a:pPr>
             <a:r>
@@ -6256,6 +6666,13 @@
             <a:prstDash val="solid"/>
           </a:ln>
         </p:spPr>
+        <p:txBody>
+          <a:bodyPr/>
+          <a:lstStyle/>
+          <a:p>
+            <a:endParaRPr lang="es-MX"/>
+          </a:p>
+        </p:txBody>
       </p:sp>
       <p:sp>
         <p:nvSpPr>
@@ -6280,7 +6697,7 @@
           </a:bodyPr>
           <a:lstStyle/>
           <a:p>
-            <a:pPr algn="l" indent="0" marL="0">
+            <a:pPr marL="0" indent="0" algn="l">
               <a:buNone/>
             </a:pPr>
             <a:r>
@@ -6322,6 +6739,13 @@
             <a:prstDash val="solid"/>
           </a:ln>
         </p:spPr>
+        <p:txBody>
+          <a:bodyPr/>
+          <a:lstStyle/>
+          <a:p>
+            <a:endParaRPr lang="es-MX"/>
+          </a:p>
+        </p:txBody>
       </p:sp>
       <p:sp>
         <p:nvSpPr>
@@ -6346,7 +6770,7 @@
           </a:bodyPr>
           <a:lstStyle/>
           <a:p>
-            <a:pPr algn="l" indent="0" marL="0">
+            <a:pPr marL="0" indent="0" algn="l">
               <a:buNone/>
             </a:pPr>
             <a:r>
@@ -6388,6 +6812,13 @@
             <a:prstDash val="solid"/>
           </a:ln>
         </p:spPr>
+        <p:txBody>
+          <a:bodyPr/>
+          <a:lstStyle/>
+          <a:p>
+            <a:endParaRPr lang="es-MX"/>
+          </a:p>
+        </p:txBody>
       </p:sp>
       <p:sp>
         <p:nvSpPr>
@@ -6412,7 +6843,7 @@
           </a:bodyPr>
           <a:lstStyle/>
           <a:p>
-            <a:pPr algn="l" indent="0" marL="0">
+            <a:pPr marL="0" indent="0" algn="l">
               <a:buNone/>
             </a:pPr>
             <a:r>
@@ -6454,6 +6885,13 @@
             <a:prstDash val="solid"/>
           </a:ln>
         </p:spPr>
+        <p:txBody>
+          <a:bodyPr/>
+          <a:lstStyle/>
+          <a:p>
+            <a:endParaRPr lang="es-MX"/>
+          </a:p>
+        </p:txBody>
       </p:sp>
       <p:sp>
         <p:nvSpPr>
@@ -6478,7 +6916,7 @@
           </a:bodyPr>
           <a:lstStyle/>
           <a:p>
-            <a:pPr algn="l" indent="0" marL="0">
+            <a:pPr marL="0" indent="0" algn="l">
               <a:buNone/>
             </a:pPr>
             <a:r>
@@ -6520,6 +6958,13 @@
             <a:prstDash val="solid"/>
           </a:ln>
         </p:spPr>
+        <p:txBody>
+          <a:bodyPr/>
+          <a:lstStyle/>
+          <a:p>
+            <a:endParaRPr lang="es-MX"/>
+          </a:p>
+        </p:txBody>
       </p:sp>
       <p:sp>
         <p:nvSpPr>
@@ -6544,7 +6989,7 @@
           </a:bodyPr>
           <a:lstStyle/>
           <a:p>
-            <a:pPr algn="l" indent="0" marL="0">
+            <a:pPr marL="0" indent="0" algn="l">
               <a:buNone/>
             </a:pPr>
             <a:r>
@@ -6586,6 +7031,13 @@
             <a:prstDash val="solid"/>
           </a:ln>
         </p:spPr>
+        <p:txBody>
+          <a:bodyPr/>
+          <a:lstStyle/>
+          <a:p>
+            <a:endParaRPr lang="es-MX"/>
+          </a:p>
+        </p:txBody>
       </p:sp>
       <p:sp>
         <p:nvSpPr>
@@ -6610,7 +7062,7 @@
           </a:bodyPr>
           <a:lstStyle/>
           <a:p>
-            <a:pPr algn="ctr" indent="0" marL="0">
+            <a:pPr marL="0" indent="0" algn="ctr">
               <a:buNone/>
             </a:pPr>
             <a:r>
@@ -6652,6 +7104,13 @@
             <a:prstDash val="solid"/>
           </a:ln>
         </p:spPr>
+        <p:txBody>
+          <a:bodyPr/>
+          <a:lstStyle/>
+          <a:p>
+            <a:endParaRPr lang="es-MX"/>
+          </a:p>
+        </p:txBody>
       </p:sp>
       <p:sp>
         <p:nvSpPr>
@@ -6676,7 +7135,7 @@
           </a:bodyPr>
           <a:lstStyle/>
           <a:p>
-            <a:pPr algn="l" indent="0" marL="0">
+            <a:pPr marL="0" indent="0" algn="l">
               <a:buNone/>
             </a:pPr>
             <a:r>
@@ -6718,6 +7177,13 @@
             <a:prstDash val="solid"/>
           </a:ln>
         </p:spPr>
+        <p:txBody>
+          <a:bodyPr/>
+          <a:lstStyle/>
+          <a:p>
+            <a:endParaRPr lang="es-MX"/>
+          </a:p>
+        </p:txBody>
       </p:sp>
       <p:sp>
         <p:nvSpPr>
@@ -6742,7 +7208,7 @@
           </a:bodyPr>
           <a:lstStyle/>
           <a:p>
-            <a:pPr algn="l" indent="0" marL="0">
+            <a:pPr marL="0" indent="0" algn="l">
               <a:buNone/>
             </a:pPr>
             <a:r>
@@ -6784,6 +7250,13 @@
             <a:prstDash val="solid"/>
           </a:ln>
         </p:spPr>
+        <p:txBody>
+          <a:bodyPr/>
+          <a:lstStyle/>
+          <a:p>
+            <a:endParaRPr lang="es-MX"/>
+          </a:p>
+        </p:txBody>
       </p:sp>
       <p:sp>
         <p:nvSpPr>
@@ -6808,7 +7281,7 @@
           </a:bodyPr>
           <a:lstStyle/>
           <a:p>
-            <a:pPr algn="l" indent="0" marL="0">
+            <a:pPr marL="0" indent="0" algn="l">
               <a:buNone/>
             </a:pPr>
             <a:r>
@@ -6850,6 +7323,13 @@
             <a:prstDash val="solid"/>
           </a:ln>
         </p:spPr>
+        <p:txBody>
+          <a:bodyPr/>
+          <a:lstStyle/>
+          <a:p>
+            <a:endParaRPr lang="es-MX"/>
+          </a:p>
+        </p:txBody>
       </p:sp>
       <p:sp>
         <p:nvSpPr>
@@ -6874,7 +7354,7 @@
           </a:bodyPr>
           <a:lstStyle/>
           <a:p>
-            <a:pPr algn="l" indent="0" marL="0">
+            <a:pPr marL="0" indent="0" algn="l">
               <a:buNone/>
             </a:pPr>
             <a:r>
@@ -6916,6 +7396,13 @@
             <a:prstDash val="solid"/>
           </a:ln>
         </p:spPr>
+        <p:txBody>
+          <a:bodyPr/>
+          <a:lstStyle/>
+          <a:p>
+            <a:endParaRPr lang="es-MX"/>
+          </a:p>
+        </p:txBody>
       </p:sp>
       <p:sp>
         <p:nvSpPr>
@@ -6940,7 +7427,7 @@
           </a:bodyPr>
           <a:lstStyle/>
           <a:p>
-            <a:pPr algn="l" indent="0" marL="0">
+            <a:pPr marL="0" indent="0" algn="l">
               <a:buNone/>
             </a:pPr>
             <a:r>
@@ -6982,6 +7469,13 @@
             <a:prstDash val="solid"/>
           </a:ln>
         </p:spPr>
+        <p:txBody>
+          <a:bodyPr/>
+          <a:lstStyle/>
+          <a:p>
+            <a:endParaRPr lang="es-MX"/>
+          </a:p>
+        </p:txBody>
       </p:sp>
       <p:sp>
         <p:nvSpPr>
@@ -7006,7 +7500,7 @@
           </a:bodyPr>
           <a:lstStyle/>
           <a:p>
-            <a:pPr algn="ctr" indent="0" marL="0">
+            <a:pPr marL="0" indent="0" algn="ctr">
               <a:buNone/>
             </a:pPr>
             <a:r>
@@ -7048,6 +7542,13 @@
             <a:prstDash val="solid"/>
           </a:ln>
         </p:spPr>
+        <p:txBody>
+          <a:bodyPr/>
+          <a:lstStyle/>
+          <a:p>
+            <a:endParaRPr lang="es-MX"/>
+          </a:p>
+        </p:txBody>
       </p:sp>
       <p:sp>
         <p:nvSpPr>
@@ -7072,7 +7573,7 @@
           </a:bodyPr>
           <a:lstStyle/>
           <a:p>
-            <a:pPr algn="l" indent="0" marL="0">
+            <a:pPr marL="0" indent="0" algn="l">
               <a:buNone/>
             </a:pPr>
             <a:r>
@@ -7114,6 +7615,13 @@
             <a:prstDash val="solid"/>
           </a:ln>
         </p:spPr>
+        <p:txBody>
+          <a:bodyPr/>
+          <a:lstStyle/>
+          <a:p>
+            <a:endParaRPr lang="es-MX"/>
+          </a:p>
+        </p:txBody>
       </p:sp>
       <p:sp>
         <p:nvSpPr>
@@ -7138,7 +7646,7 @@
           </a:bodyPr>
           <a:lstStyle/>
           <a:p>
-            <a:pPr algn="l" indent="0" marL="0">
+            <a:pPr marL="0" indent="0" algn="l">
               <a:buNone/>
             </a:pPr>
             <a:r>
@@ -7180,6 +7688,13 @@
             <a:prstDash val="solid"/>
           </a:ln>
         </p:spPr>
+        <p:txBody>
+          <a:bodyPr/>
+          <a:lstStyle/>
+          <a:p>
+            <a:endParaRPr lang="es-MX"/>
+          </a:p>
+        </p:txBody>
       </p:sp>
       <p:sp>
         <p:nvSpPr>
@@ -7204,7 +7719,7 @@
           </a:bodyPr>
           <a:lstStyle/>
           <a:p>
-            <a:pPr algn="l" indent="0" marL="0">
+            <a:pPr marL="0" indent="0" algn="l">
               <a:buNone/>
             </a:pPr>
             <a:r>
@@ -7246,6 +7761,13 @@
             <a:prstDash val="solid"/>
           </a:ln>
         </p:spPr>
+        <p:txBody>
+          <a:bodyPr/>
+          <a:lstStyle/>
+          <a:p>
+            <a:endParaRPr lang="es-MX"/>
+          </a:p>
+        </p:txBody>
       </p:sp>
       <p:sp>
         <p:nvSpPr>
@@ -7270,7 +7792,7 @@
           </a:bodyPr>
           <a:lstStyle/>
           <a:p>
-            <a:pPr algn="l" indent="0" marL="0">
+            <a:pPr marL="0" indent="0" algn="l">
               <a:buNone/>
             </a:pPr>
             <a:r>
@@ -7312,6 +7834,13 @@
             <a:prstDash val="solid"/>
           </a:ln>
         </p:spPr>
+        <p:txBody>
+          <a:bodyPr/>
+          <a:lstStyle/>
+          <a:p>
+            <a:endParaRPr lang="es-MX"/>
+          </a:p>
+        </p:txBody>
       </p:sp>
       <p:sp>
         <p:nvSpPr>
@@ -7336,7 +7865,7 @@
           </a:bodyPr>
           <a:lstStyle/>
           <a:p>
-            <a:pPr algn="l" indent="0" marL="0">
+            <a:pPr marL="0" indent="0" algn="l">
               <a:buNone/>
             </a:pPr>
             <a:r>
@@ -7378,6 +7907,13 @@
             <a:prstDash val="solid"/>
           </a:ln>
         </p:spPr>
+        <p:txBody>
+          <a:bodyPr/>
+          <a:lstStyle/>
+          <a:p>
+            <a:endParaRPr lang="es-MX"/>
+          </a:p>
+        </p:txBody>
       </p:sp>
       <p:sp>
         <p:nvSpPr>
@@ -7402,7 +7938,7 @@
           </a:bodyPr>
           <a:lstStyle/>
           <a:p>
-            <a:pPr algn="ctr" indent="0" marL="0">
+            <a:pPr marL="0" indent="0" algn="ctr">
               <a:buNone/>
             </a:pPr>
             <a:r>
@@ -7444,6 +7980,13 @@
             <a:prstDash val="solid"/>
           </a:ln>
         </p:spPr>
+        <p:txBody>
+          <a:bodyPr/>
+          <a:lstStyle/>
+          <a:p>
+            <a:endParaRPr lang="es-MX"/>
+          </a:p>
+        </p:txBody>
       </p:sp>
       <p:sp>
         <p:nvSpPr>
@@ -7468,7 +8011,7 @@
           </a:bodyPr>
           <a:lstStyle/>
           <a:p>
-            <a:pPr algn="l" indent="0" marL="0">
+            <a:pPr marL="0" indent="0" algn="l">
               <a:buNone/>
             </a:pPr>
             <a:r>
@@ -7510,6 +8053,13 @@
             <a:prstDash val="solid"/>
           </a:ln>
         </p:spPr>
+        <p:txBody>
+          <a:bodyPr/>
+          <a:lstStyle/>
+          <a:p>
+            <a:endParaRPr lang="es-MX"/>
+          </a:p>
+        </p:txBody>
       </p:sp>
       <p:sp>
         <p:nvSpPr>
@@ -7534,7 +8084,7 @@
           </a:bodyPr>
           <a:lstStyle/>
           <a:p>
-            <a:pPr algn="l" indent="0" marL="0">
+            <a:pPr marL="0" indent="0" algn="l">
               <a:buNone/>
             </a:pPr>
             <a:r>
@@ -7576,6 +8126,13 @@
             <a:prstDash val="solid"/>
           </a:ln>
         </p:spPr>
+        <p:txBody>
+          <a:bodyPr/>
+          <a:lstStyle/>
+          <a:p>
+            <a:endParaRPr lang="es-MX"/>
+          </a:p>
+        </p:txBody>
       </p:sp>
       <p:sp>
         <p:nvSpPr>
@@ -7600,7 +8157,7 @@
           </a:bodyPr>
           <a:lstStyle/>
           <a:p>
-            <a:pPr algn="l" indent="0" marL="0">
+            <a:pPr marL="0" indent="0" algn="l">
               <a:buNone/>
             </a:pPr>
             <a:r>
@@ -7642,6 +8199,13 @@
             <a:prstDash val="solid"/>
           </a:ln>
         </p:spPr>
+        <p:txBody>
+          <a:bodyPr/>
+          <a:lstStyle/>
+          <a:p>
+            <a:endParaRPr lang="es-MX"/>
+          </a:p>
+        </p:txBody>
       </p:sp>
       <p:sp>
         <p:nvSpPr>
@@ -7666,7 +8230,7 @@
           </a:bodyPr>
           <a:lstStyle/>
           <a:p>
-            <a:pPr algn="l" indent="0" marL="0">
+            <a:pPr marL="0" indent="0" algn="l">
               <a:buNone/>
             </a:pPr>
             <a:r>
@@ -7708,6 +8272,13 @@
             <a:prstDash val="solid"/>
           </a:ln>
         </p:spPr>
+        <p:txBody>
+          <a:bodyPr/>
+          <a:lstStyle/>
+          <a:p>
+            <a:endParaRPr lang="es-MX"/>
+          </a:p>
+        </p:txBody>
       </p:sp>
       <p:sp>
         <p:nvSpPr>
@@ -7732,7 +8303,7 @@
           </a:bodyPr>
           <a:lstStyle/>
           <a:p>
-            <a:pPr algn="l" indent="0" marL="0">
+            <a:pPr marL="0" indent="0" algn="l">
               <a:buNone/>
             </a:pPr>
             <a:r>
@@ -7766,6 +8337,7 @@
         <a:solidFill>
           <a:srgbClr val="FFFFFF"/>
         </a:solidFill>
+        <a:effectLst/>
       </p:bgPr>
     </p:bg>
     <p:spTree>
@@ -7806,6 +8378,13 @@
             <a:prstDash val="solid"/>
           </a:ln>
         </p:spPr>
+        <p:txBody>
+          <a:bodyPr/>
+          <a:lstStyle/>
+          <a:p>
+            <a:endParaRPr lang="es-MX"/>
+          </a:p>
+        </p:txBody>
       </p:sp>
       <p:sp>
         <p:nvSpPr>
@@ -7828,11 +8407,11 @@
           <a:bodyPr wrap="square" lIns="0" tIns="0" rIns="0" bIns="0" rtlCol="0" anchor="ctr"/>
           <a:lstStyle/>
           <a:p>
-            <a:pPr indent="0" marL="0">
-              <a:buNone/>
-            </a:pPr>
-            <a:r>
-              <a:rPr lang="en-US" sz="900" b="1" spc="120" kern="0" dirty="0">
+            <a:pPr marL="0" indent="0">
+              <a:buNone/>
+            </a:pPr>
+            <a:r>
+              <a:rPr lang="en-US" sz="900" b="1" kern="0" spc="120" dirty="0">
                 <a:solidFill>
                   <a:srgbClr val="5B8296"/>
                 </a:solidFill>
@@ -7867,7 +8446,7 @@
           <a:bodyPr wrap="square" lIns="0" tIns="0" rIns="0" bIns="0" rtlCol="0" anchor="ctr"/>
           <a:lstStyle/>
           <a:p>
-            <a:pPr indent="0" marL="0">
+            <a:pPr marL="0" indent="0">
               <a:buNone/>
             </a:pPr>
             <a:r>
@@ -7887,14 +8466,14 @@
       </p:sp>
       <p:pic>
         <p:nvPicPr>
-          <p:cNvPr id="5" name="Image 0" descr="/mnt/data/work_jama/ppt/media/image1.png">    </p:cNvPr>
+          <p:cNvPr id="5" name="Image 0" descr="/mnt/data/work_jama/ppt/media/image1.png"/>
           <p:cNvPicPr>
             <a:picLocks noChangeAspect="1"/>
           </p:cNvPicPr>
           <p:nvPr/>
         </p:nvPicPr>
         <p:blipFill>
-          <a:blip r:embed="rId1"/>
+          <a:blip r:embed="rId3"/>
           <a:stretch>
             <a:fillRect/>
           </a:stretch>
@@ -7930,7 +8509,7 @@
           <a:bodyPr wrap="square" lIns="0" tIns="0" rIns="0" bIns="0" rtlCol="0" anchor="ctr"/>
           <a:lstStyle/>
           <a:p>
-            <a:pPr algn="r" indent="0" marL="0">
+            <a:pPr marL="0" indent="0" algn="r">
               <a:buNone/>
             </a:pPr>
             <a:r>
@@ -7967,6 +8546,13 @@
             <a:prstDash val="solid"/>
           </a:ln>
         </p:spPr>
+        <p:txBody>
+          <a:bodyPr/>
+          <a:lstStyle/>
+          <a:p>
+            <a:endParaRPr lang="es-MX"/>
+          </a:p>
+        </p:txBody>
       </p:sp>
       <p:sp>
         <p:nvSpPr>
@@ -7994,6 +8580,13 @@
             <a:prstDash val="solid"/>
           </a:ln>
         </p:spPr>
+        <p:txBody>
+          <a:bodyPr/>
+          <a:lstStyle/>
+          <a:p>
+            <a:endParaRPr lang="es-MX"/>
+          </a:p>
+        </p:txBody>
       </p:sp>
       <p:sp>
         <p:nvSpPr>
@@ -8021,6 +8614,13 @@
             <a:prstDash val="solid"/>
           </a:ln>
         </p:spPr>
+        <p:txBody>
+          <a:bodyPr/>
+          <a:lstStyle/>
+          <a:p>
+            <a:endParaRPr lang="es-MX"/>
+          </a:p>
+        </p:txBody>
       </p:sp>
       <p:sp>
         <p:nvSpPr>
@@ -8045,7 +8645,7 @@
           </a:bodyPr>
           <a:lstStyle/>
           <a:p>
-            <a:pPr algn="ctr" indent="0" marL="0">
+            <a:pPr marL="0" indent="0" algn="ctr">
               <a:buNone/>
             </a:pPr>
             <a:r>
@@ -8086,7 +8686,7 @@
           </a:bodyPr>
           <a:lstStyle/>
           <a:p>
-            <a:pPr indent="0" marL="0">
+            <a:pPr marL="0" indent="0">
               <a:buNone/>
             </a:pPr>
             <a:r>
@@ -8127,7 +8727,7 @@
           </a:bodyPr>
           <a:lstStyle/>
           <a:p>
-            <a:pPr indent="0" marL="0">
+            <a:pPr marL="0" indent="0">
               <a:buNone/>
             </a:pPr>
             <a:r>
@@ -8168,7 +8768,7 @@
           </a:bodyPr>
           <a:lstStyle/>
           <a:p>
-            <a:pPr indent="0" marL="0">
+            <a:pPr marL="0" indent="0">
               <a:buNone/>
             </a:pPr>
             <a:r>
@@ -8209,7 +8809,7 @@
           </a:bodyPr>
           <a:lstStyle/>
           <a:p>
-            <a:pPr indent="0" marL="0">
+            <a:pPr marL="0" indent="0">
               <a:buNone/>
             </a:pPr>
             <a:r>
@@ -8250,7 +8850,7 @@
           </a:bodyPr>
           <a:lstStyle/>
           <a:p>
-            <a:pPr indent="0" marL="0">
+            <a:pPr marL="0" indent="0">
               <a:buNone/>
             </a:pPr>
             <a:r>
@@ -8291,7 +8891,7 @@
           </a:bodyPr>
           <a:lstStyle/>
           <a:p>
-            <a:pPr indent="0" marL="0">
+            <a:pPr marL="0" indent="0">
               <a:buNone/>
             </a:pPr>
             <a:r>
@@ -8332,7 +8932,7 @@
           </a:bodyPr>
           <a:lstStyle/>
           <a:p>
-            <a:pPr indent="0" marL="0">
+            <a:pPr marL="0" indent="0">
               <a:buNone/>
             </a:pPr>
             <a:r>
@@ -8373,7 +8973,7 @@
           </a:bodyPr>
           <a:lstStyle/>
           <a:p>
-            <a:pPr indent="0" marL="0">
+            <a:pPr marL="0" indent="0">
               <a:buNone/>
             </a:pPr>
             <a:r>
@@ -8414,7 +9014,7 @@
           </a:bodyPr>
           <a:lstStyle/>
           <a:p>
-            <a:pPr indent="0" marL="0">
+            <a:pPr marL="0" indent="0">
               <a:buNone/>
             </a:pPr>
             <a:r>
@@ -8458,6 +9058,13 @@
             <a:prstDash val="solid"/>
           </a:ln>
         </p:spPr>
+        <p:txBody>
+          <a:bodyPr/>
+          <a:lstStyle/>
+          <a:p>
+            <a:endParaRPr lang="es-MX"/>
+          </a:p>
+        </p:txBody>
       </p:sp>
       <p:sp>
         <p:nvSpPr>
@@ -8485,6 +9092,13 @@
             <a:prstDash val="solid"/>
           </a:ln>
         </p:spPr>
+        <p:txBody>
+          <a:bodyPr/>
+          <a:lstStyle/>
+          <a:p>
+            <a:endParaRPr lang="es-MX"/>
+          </a:p>
+        </p:txBody>
       </p:sp>
       <p:sp>
         <p:nvSpPr>
@@ -8509,7 +9123,7 @@
           </a:bodyPr>
           <a:lstStyle/>
           <a:p>
-            <a:pPr algn="ctr" indent="0" marL="0">
+            <a:pPr marL="0" indent="0" algn="ctr">
               <a:buNone/>
             </a:pPr>
             <a:r>
@@ -8550,7 +9164,7 @@
           </a:bodyPr>
           <a:lstStyle/>
           <a:p>
-            <a:pPr indent="0" marL="0">
+            <a:pPr marL="0" indent="0">
               <a:buNone/>
             </a:pPr>
             <a:r>
@@ -8592,6 +9206,13 @@
             <a:prstDash val="solid"/>
           </a:ln>
         </p:spPr>
+        <p:txBody>
+          <a:bodyPr/>
+          <a:lstStyle/>
+          <a:p>
+            <a:endParaRPr lang="es-MX"/>
+          </a:p>
+        </p:txBody>
       </p:sp>
       <p:sp>
         <p:nvSpPr>
@@ -8616,7 +9237,7 @@
           </a:bodyPr>
           <a:lstStyle/>
           <a:p>
-            <a:pPr algn="ctr" indent="0" marL="0">
+            <a:pPr marL="0" indent="0" algn="ctr">
               <a:buNone/>
             </a:pPr>
             <a:r>
@@ -8657,7 +9278,7 @@
           </a:bodyPr>
           <a:lstStyle/>
           <a:p>
-            <a:pPr indent="0" marL="0">
+            <a:pPr marL="0" indent="0">
               <a:buNone/>
             </a:pPr>
             <a:r>
@@ -8698,7 +9319,7 @@
           </a:bodyPr>
           <a:lstStyle/>
           <a:p>
-            <a:pPr indent="0" marL="0">
+            <a:pPr marL="0" indent="0">
               <a:buNone/>
             </a:pPr>
             <a:r>
@@ -8740,6 +9361,13 @@
             <a:prstDash val="solid"/>
           </a:ln>
         </p:spPr>
+        <p:txBody>
+          <a:bodyPr/>
+          <a:lstStyle/>
+          <a:p>
+            <a:endParaRPr lang="es-MX"/>
+          </a:p>
+        </p:txBody>
       </p:sp>
       <p:sp>
         <p:nvSpPr>
@@ -8764,7 +9392,7 @@
           </a:bodyPr>
           <a:lstStyle/>
           <a:p>
-            <a:pPr algn="ctr" indent="0" marL="0">
+            <a:pPr marL="0" indent="0" algn="ctr">
               <a:buNone/>
             </a:pPr>
             <a:r>
@@ -8805,7 +9433,7 @@
           </a:bodyPr>
           <a:lstStyle/>
           <a:p>
-            <a:pPr indent="0" marL="0">
+            <a:pPr marL="0" indent="0">
               <a:buNone/>
             </a:pPr>
             <a:r>
@@ -8846,7 +9474,7 @@
           </a:bodyPr>
           <a:lstStyle/>
           <a:p>
-            <a:pPr indent="0" marL="0">
+            <a:pPr marL="0" indent="0">
               <a:buNone/>
             </a:pPr>
             <a:r>
@@ -8888,6 +9516,13 @@
             <a:prstDash val="solid"/>
           </a:ln>
         </p:spPr>
+        <p:txBody>
+          <a:bodyPr/>
+          <a:lstStyle/>
+          <a:p>
+            <a:endParaRPr lang="es-MX"/>
+          </a:p>
+        </p:txBody>
       </p:sp>
       <p:sp>
         <p:nvSpPr>
@@ -8912,7 +9547,7 @@
           </a:bodyPr>
           <a:lstStyle/>
           <a:p>
-            <a:pPr algn="ctr" indent="0" marL="0">
+            <a:pPr marL="0" indent="0" algn="ctr">
               <a:buNone/>
             </a:pPr>
             <a:r>
@@ -8953,7 +9588,7 @@
           </a:bodyPr>
           <a:lstStyle/>
           <a:p>
-            <a:pPr indent="0" marL="0">
+            <a:pPr marL="0" indent="0">
               <a:buNone/>
             </a:pPr>
             <a:r>
@@ -8994,7 +9629,7 @@
           </a:bodyPr>
           <a:lstStyle/>
           <a:p>
-            <a:pPr indent="0" marL="0">
+            <a:pPr marL="0" indent="0">
               <a:buNone/>
             </a:pPr>
             <a:r>
@@ -9036,6 +9671,13 @@
             <a:prstDash val="solid"/>
           </a:ln>
         </p:spPr>
+        <p:txBody>
+          <a:bodyPr/>
+          <a:lstStyle/>
+          <a:p>
+            <a:endParaRPr lang="es-MX"/>
+          </a:p>
+        </p:txBody>
       </p:sp>
       <p:sp>
         <p:nvSpPr>
@@ -9060,7 +9702,7 @@
           </a:bodyPr>
           <a:lstStyle/>
           <a:p>
-            <a:pPr algn="ctr" indent="0" marL="0">
+            <a:pPr marL="0" indent="0" algn="ctr">
               <a:buNone/>
             </a:pPr>
             <a:r>
@@ -9101,7 +9743,7 @@
           </a:bodyPr>
           <a:lstStyle/>
           <a:p>
-            <a:pPr indent="0" marL="0">
+            <a:pPr marL="0" indent="0">
               <a:buNone/>
             </a:pPr>
             <a:r>
@@ -9142,7 +9784,7 @@
           </a:bodyPr>
           <a:lstStyle/>
           <a:p>
-            <a:pPr indent="0" marL="0">
+            <a:pPr marL="0" indent="0">
               <a:buNone/>
             </a:pPr>
             <a:r>
@@ -9157,6 +9799,1532 @@
               <a:t>Trabajador, jefatura, gerencia si aplica y validación DO.</a:t>
             </a:r>
             <a:endParaRPr lang="en-US" sz="1020" dirty="0"/>
+          </a:p>
+        </p:txBody>
+      </p:sp>
+    </p:spTree>
+  </p:cSld>
+  <p:clrMapOvr>
+    <a:masterClrMapping/>
+  </p:clrMapOvr>
+</p:sld>
+</file>
+
+<file path=ppt/slides/slide6.xml><?xml version="1.0" encoding="utf-8"?>
+<p:sld xmlns:a="http://schemas.openxmlformats.org/drawingml/2006/main" xmlns:r="http://schemas.openxmlformats.org/officeDocument/2006/relationships" xmlns:p="http://schemas.openxmlformats.org/presentationml/2006/main">
+  <p:cSld>
+    <p:bg>
+      <p:bgPr>
+        <a:solidFill>
+          <a:srgbClr val="FFFFFF"/>
+        </a:solidFill>
+        <a:effectLst/>
+      </p:bgPr>
+    </p:bg>
+    <p:spTree>
+      <p:nvGrpSpPr>
+        <p:cNvPr id="1" name=""/>
+        <p:cNvGrpSpPr/>
+        <p:nvPr/>
+      </p:nvGrpSpPr>
+      <p:grpSpPr>
+        <a:xfrm>
+          <a:off x="0" y="0"/>
+          <a:ext cx="0" cy="0"/>
+          <a:chOff x="0" y="0"/>
+          <a:chExt cx="0" cy="0"/>
+        </a:xfrm>
+      </p:grpSpPr>
+      <p:sp>
+        <p:nvSpPr>
+          <p:cNvPr id="2" name="Shape 0"/>
+          <p:cNvSpPr/>
+          <p:nvPr/>
+        </p:nvSpPr>
+        <p:spPr>
+          <a:xfrm>
+            <a:off x="0" y="0"/>
+            <a:ext cx="12191695" cy="146304"/>
+          </a:xfrm>
+          <a:prstGeom prst="rect">
+            <a:avLst/>
+          </a:prstGeom>
+          <a:solidFill>
+            <a:srgbClr val="002D62"/>
+          </a:solidFill>
+          <a:ln w="12700">
+            <a:solidFill>
+              <a:srgbClr val="002D62"/>
+            </a:solidFill>
+            <a:prstDash val="solid"/>
+          </a:ln>
+        </p:spPr>
+        <p:txBody>
+          <a:bodyPr/>
+          <a:lstStyle/>
+          <a:p>
+            <a:endParaRPr lang="es-MX"/>
+          </a:p>
+        </p:txBody>
+      </p:sp>
+      <p:sp>
+        <p:nvSpPr>
+          <p:cNvPr id="3" name="Text 1"/>
+          <p:cNvSpPr/>
+          <p:nvPr/>
+        </p:nvSpPr>
+        <p:spPr>
+          <a:xfrm>
+            <a:off x="502920" y="310896"/>
+            <a:ext cx="7315200" cy="201168"/>
+          </a:xfrm>
+          <a:prstGeom prst="rect">
+            <a:avLst/>
+          </a:prstGeom>
+          <a:noFill/>
+          <a:ln/>
+        </p:spPr>
+        <p:txBody>
+          <a:bodyPr wrap="square" lIns="0" tIns="0" rIns="0" bIns="0" rtlCol="0" anchor="ctr"/>
+          <a:lstStyle/>
+          <a:p>
+            <a:pPr marL="0" indent="0">
+              <a:buNone/>
+            </a:pPr>
+            <a:r>
+              <a:rPr lang="en-US" sz="900" b="1" kern="0" spc="120">
+                <a:solidFill>
+                  <a:srgbClr val="5B8296"/>
+                </a:solidFill>
+                <a:latin typeface="Aptos" pitchFamily="34" charset="0"/>
+                <a:ea typeface="Aptos" pitchFamily="34" charset="-122"/>
+                <a:cs typeface="Aptos" pitchFamily="34" charset="-120"/>
+              </a:rPr>
+              <a:t>MÓDULO 5 · ACTUALIZACIÓN DE SALDOS</a:t>
+            </a:r>
+            <a:endParaRPr lang="en-US" sz="900"/>
+          </a:p>
+        </p:txBody>
+      </p:sp>
+      <p:sp>
+        <p:nvSpPr>
+          <p:cNvPr id="4" name="Text 2"/>
+          <p:cNvSpPr/>
+          <p:nvPr/>
+        </p:nvSpPr>
+        <p:spPr>
+          <a:xfrm>
+            <a:off x="502920" y="566928"/>
+            <a:ext cx="10515600" cy="420624"/>
+          </a:xfrm>
+          <a:prstGeom prst="rect">
+            <a:avLst/>
+          </a:prstGeom>
+          <a:noFill/>
+          <a:ln/>
+        </p:spPr>
+        <p:txBody>
+          <a:bodyPr wrap="square" lIns="0" tIns="0" rIns="0" bIns="0" rtlCol="0" anchor="ctr"/>
+          <a:lstStyle/>
+          <a:p>
+            <a:pPr marL="0" indent="0">
+              <a:buNone/>
+            </a:pPr>
+            <a:r>
+              <a:rPr lang="en-US" sz="2700" b="1">
+                <a:solidFill>
+                  <a:srgbClr val="002D62"/>
+                </a:solidFill>
+                <a:latin typeface="Aptos Display" pitchFamily="34" charset="0"/>
+                <a:ea typeface="Aptos Display" pitchFamily="34" charset="-122"/>
+                <a:cs typeface="Aptos Display" pitchFamily="34" charset="-120"/>
+              </a:rPr>
+              <a:t>¿Cómo opera la actualización automática?</a:t>
+            </a:r>
+            <a:endParaRPr lang="en-US" sz="2700"/>
+          </a:p>
+        </p:txBody>
+      </p:sp>
+      <p:pic>
+        <p:nvPicPr>
+          <p:cNvPr id="5" name="Image 0" descr="/mnt/data/work_jama/ppt/media/image1.png"/>
+          <p:cNvPicPr>
+            <a:picLocks noChangeAspect="1"/>
+          </p:cNvPicPr>
+          <p:nvPr/>
+        </p:nvPicPr>
+        <p:blipFill>
+          <a:blip r:embed="rId3"/>
+          <a:stretch>
+            <a:fillRect/>
+          </a:stretch>
+        </p:blipFill>
+        <p:spPr>
+          <a:xfrm>
+            <a:off x="10561320" y="338328"/>
+            <a:ext cx="1097280" cy="274320"/>
+          </a:xfrm>
+          <a:prstGeom prst="rect">
+            <a:avLst/>
+          </a:prstGeom>
+        </p:spPr>
+      </p:pic>
+      <p:sp>
+        <p:nvSpPr>
+          <p:cNvPr id="6" name="Text 3"/>
+          <p:cNvSpPr/>
+          <p:nvPr/>
+        </p:nvSpPr>
+        <p:spPr>
+          <a:xfrm>
+            <a:off x="11201400" y="6382512"/>
+            <a:ext cx="438912" cy="182880"/>
+          </a:xfrm>
+          <a:prstGeom prst="rect">
+            <a:avLst/>
+          </a:prstGeom>
+          <a:noFill/>
+          <a:ln/>
+        </p:spPr>
+        <p:txBody>
+          <a:bodyPr wrap="square" lIns="0" tIns="0" rIns="0" bIns="0" rtlCol="0" anchor="ctr"/>
+          <a:lstStyle/>
+          <a:p>
+            <a:pPr marL="0" indent="0" algn="r">
+              <a:buNone/>
+            </a:pPr>
+            <a:r>
+              <a:rPr lang="en-US" sz="800" b="1">
+                <a:solidFill>
+                  <a:srgbClr val="5B8296"/>
+                </a:solidFill>
+              </a:rPr>
+              <a:t>06</a:t>
+            </a:r>
+            <a:endParaRPr lang="en-US" sz="800"/>
+          </a:p>
+        </p:txBody>
+      </p:sp>
+      <p:sp>
+        <p:nvSpPr>
+          <p:cNvPr id="7" name="Shape 4"/>
+          <p:cNvSpPr/>
+          <p:nvPr/>
+        </p:nvSpPr>
+        <p:spPr>
+          <a:xfrm>
+            <a:off x="502920" y="6318504"/>
+            <a:ext cx="11155680" cy="1"/>
+          </a:xfrm>
+          <a:prstGeom prst="line">
+            <a:avLst/>
+          </a:prstGeom>
+          <a:noFill/>
+          <a:ln w="12700">
+            <a:solidFill>
+              <a:srgbClr val="D9E2E8"/>
+            </a:solidFill>
+            <a:prstDash val="solid"/>
+          </a:ln>
+        </p:spPr>
+        <p:txBody>
+          <a:bodyPr/>
+          <a:lstStyle/>
+          <a:p>
+            <a:endParaRPr lang="es-MX"/>
+          </a:p>
+        </p:txBody>
+      </p:sp>
+      <p:sp>
+        <p:nvSpPr>
+          <p:cNvPr id="9" name="Rectangle 8"/>
+          <p:cNvSpPr/>
+          <p:nvPr/>
+        </p:nvSpPr>
+        <p:spPr>
+          <a:xfrm>
+            <a:off x="502920" y="1737360"/>
+            <a:ext cx="11155680" cy="749808"/>
+          </a:xfrm>
+          <a:prstGeom prst="rect">
+            <a:avLst/>
+          </a:prstGeom>
+          <a:solidFill>
+            <a:srgbClr val="F4F7F9"/>
+          </a:solidFill>
+          <a:ln>
+            <a:noFill/>
+          </a:ln>
+        </p:spPr>
+        <p:style>
+          <a:lnRef idx="1">
+            <a:schemeClr val="accent1"/>
+          </a:lnRef>
+          <a:fillRef idx="3">
+            <a:schemeClr val="accent1"/>
+          </a:fillRef>
+          <a:effectRef idx="2">
+            <a:schemeClr val="accent1"/>
+          </a:effectRef>
+          <a:fontRef idx="minor">
+            <a:schemeClr val="lt1"/>
+          </a:fontRef>
+        </p:style>
+        <p:txBody>
+          <a:bodyPr rtlCol="0" anchor="ctr"/>
+          <a:lstStyle/>
+          <a:p>
+            <a:pPr algn="ctr"/>
+            <a:endParaRPr/>
+          </a:p>
+        </p:txBody>
+      </p:sp>
+      <p:sp>
+        <p:nvSpPr>
+          <p:cNvPr id="12" name="TextBox 11"/>
+          <p:cNvSpPr txBox="1"/>
+          <p:nvPr/>
+        </p:nvSpPr>
+        <p:spPr>
+          <a:xfrm>
+            <a:off x="502920" y="2862072"/>
+            <a:ext cx="3547872" cy="420624"/>
+          </a:xfrm>
+          <a:prstGeom prst="rect">
+            <a:avLst/>
+          </a:prstGeom>
+          <a:noFill/>
+        </p:spPr>
+        <p:txBody>
+          <a:bodyPr wrap="square" lIns="0" tIns="0" rIns="0" bIns="0">
+            <a:spAutoFit/>
+          </a:bodyPr>
+          <a:lstStyle/>
+          <a:p>
+            <a:pPr>
+              <a:spcAft>
+                <a:spcPts val="500"/>
+              </a:spcAft>
+              <a:defRPr sz="1700" b="1">
+                <a:solidFill>
+                  <a:srgbClr val="002D62"/>
+                </a:solidFill>
+                <a:latin typeface="Aptos"/>
+              </a:defRPr>
+            </a:pPr>
+            <a:r>
+              <a:t>01  Nuevos aniversarios</a:t>
+            </a:r>
+          </a:p>
+        </p:txBody>
+      </p:sp>
+      <p:sp>
+        <p:nvSpPr>
+          <p:cNvPr id="13" name="TextBox 12"/>
+          <p:cNvSpPr txBox="1"/>
+          <p:nvPr/>
+        </p:nvSpPr>
+        <p:spPr>
+          <a:xfrm>
+            <a:off x="502920" y="3520440"/>
+            <a:ext cx="3520440" cy="2258568"/>
+          </a:xfrm>
+          <a:prstGeom prst="rect">
+            <a:avLst/>
+          </a:prstGeom>
+          <a:noFill/>
+        </p:spPr>
+        <p:txBody>
+          <a:bodyPr wrap="square" lIns="0" tIns="0" rIns="0" bIns="0">
+            <a:spAutoFit/>
+          </a:bodyPr>
+          <a:lstStyle/>
+          <a:p>
+            <a:pPr>
+              <a:spcAft>
+                <a:spcPts val="500"/>
+              </a:spcAft>
+              <a:defRPr sz="1400" b="0">
+                <a:solidFill>
+                  <a:srgbClr val="333333"/>
+                </a:solidFill>
+                <a:latin typeface="Aptos"/>
+              </a:defRPr>
+            </a:pPr>
+            <a:r>
+              <a:t>En cada aniversario, crea el ciclo anual y asigna los días de derecho según Vacaciones Dignas (LFT).</a:t>
+            </a:r>
+          </a:p>
+          <a:p>
+            <a:pPr>
+              <a:spcAft>
+                <a:spcPts val="500"/>
+              </a:spcAft>
+              <a:defRPr sz="1400" b="0">
+                <a:solidFill>
+                  <a:srgbClr val="333333"/>
+                </a:solidFill>
+                <a:latin typeface="Aptos"/>
+              </a:defRPr>
+            </a:pPr>
+            <a:r>
+              <a:t>Ejemplo: de 5 a 6 años de servicio. Ciclo anual ilustrativo: 2025–2026.</a:t>
+            </a:r>
+          </a:p>
+          <a:p>
+            <a:pPr>
+              <a:spcAft>
+                <a:spcPts val="500"/>
+              </a:spcAft>
+              <a:defRPr sz="1400" b="0">
+                <a:solidFill>
+                  <a:srgbClr val="333333"/>
+                </a:solidFill>
+                <a:latin typeface="Aptos"/>
+              </a:defRPr>
+            </a:pPr>
+            <a:r>
+              <a:t>Días por ley: 12, 14, 16, 18, 20, 22…</a:t>
+            </a:r>
+          </a:p>
+        </p:txBody>
+      </p:sp>
+      <p:sp>
+        <p:nvSpPr>
+          <p:cNvPr id="14" name="TextBox 13"/>
+          <p:cNvSpPr txBox="1"/>
+          <p:nvPr/>
+        </p:nvSpPr>
+        <p:spPr>
+          <a:xfrm>
+            <a:off x="4315968" y="2862072"/>
+            <a:ext cx="3547872" cy="420624"/>
+          </a:xfrm>
+          <a:prstGeom prst="rect">
+            <a:avLst/>
+          </a:prstGeom>
+          <a:noFill/>
+        </p:spPr>
+        <p:txBody>
+          <a:bodyPr wrap="square" lIns="0" tIns="0" rIns="0" bIns="0">
+            <a:spAutoFit/>
+          </a:bodyPr>
+          <a:lstStyle/>
+          <a:p>
+            <a:pPr>
+              <a:spcAft>
+                <a:spcPts val="500"/>
+              </a:spcAft>
+              <a:defRPr sz="1700" b="1">
+                <a:solidFill>
+                  <a:srgbClr val="002D62"/>
+                </a:solidFill>
+                <a:latin typeface="Aptos"/>
+              </a:defRPr>
+            </a:pPr>
+            <a:r>
+              <a:t>02  Vigencia de 18 meses</a:t>
+            </a:r>
+          </a:p>
+        </p:txBody>
+      </p:sp>
+      <p:sp>
+        <p:nvSpPr>
+          <p:cNvPr id="15" name="TextBox 14"/>
+          <p:cNvSpPr txBox="1"/>
+          <p:nvPr/>
+        </p:nvSpPr>
+        <p:spPr>
+          <a:xfrm>
+            <a:off x="4315968" y="3520440"/>
+            <a:ext cx="3520440" cy="2258568"/>
+          </a:xfrm>
+          <a:prstGeom prst="rect">
+            <a:avLst/>
+          </a:prstGeom>
+          <a:noFill/>
+        </p:spPr>
+        <p:txBody>
+          <a:bodyPr wrap="square" lIns="0" tIns="0" rIns="0" bIns="0">
+            <a:spAutoFit/>
+          </a:bodyPr>
+          <a:lstStyle/>
+          <a:p>
+            <a:pPr>
+              <a:spcAft>
+                <a:spcPts val="500"/>
+              </a:spcAft>
+              <a:defRPr sz="1400" b="0">
+                <a:solidFill>
+                  <a:srgbClr val="333333"/>
+                </a:solidFill>
+                <a:latin typeface="Aptos"/>
+              </a:defRPr>
+            </a:pPr>
+            <a:r>
+              <a:t>FechaFinVigencia =</a:t>
+            </a:r>
+          </a:p>
+          <a:p>
+            <a:pPr>
+              <a:spcAft>
+                <a:spcPts val="500"/>
+              </a:spcAft>
+              <a:defRPr sz="1400" b="0">
+                <a:solidFill>
+                  <a:srgbClr val="333333"/>
+                </a:solidFill>
+                <a:latin typeface="Aptos"/>
+              </a:defRPr>
+            </a:pPr>
+            <a:r>
+              <a:t>FechaAniversario + 18 meses</a:t>
+            </a:r>
+          </a:p>
+          <a:p>
+            <a:pPr>
+              <a:spcAft>
+                <a:spcPts val="500"/>
+              </a:spcAft>
+              <a:defRPr sz="1400" b="0">
+                <a:solidFill>
+                  <a:srgbClr val="333333"/>
+                </a:solidFill>
+                <a:latin typeface="Aptos"/>
+              </a:defRPr>
+            </a:pPr>
+            <a:r>
+              <a:t>Si la fecha actual rebasa el límite, el ciclo pasa a CADUCADO / PRESCRITO.</a:t>
+            </a:r>
+          </a:p>
+          <a:p>
+            <a:pPr>
+              <a:spcAft>
+                <a:spcPts val="500"/>
+              </a:spcAft>
+              <a:defRPr sz="1400" b="0">
+                <a:solidFill>
+                  <a:srgbClr val="333333"/>
+                </a:solidFill>
+                <a:latin typeface="Aptos"/>
+              </a:defRPr>
+            </a:pPr>
+            <a:r>
+              <a:t>Los días restantes dejan de sumar al saldo disponible.</a:t>
+            </a:r>
+          </a:p>
+        </p:txBody>
+      </p:sp>
+      <p:sp>
+        <p:nvSpPr>
+          <p:cNvPr id="16" name="TextBox 15"/>
+          <p:cNvSpPr txBox="1"/>
+          <p:nvPr/>
+        </p:nvSpPr>
+        <p:spPr>
+          <a:xfrm>
+            <a:off x="8129016" y="2862072"/>
+            <a:ext cx="3547872" cy="420624"/>
+          </a:xfrm>
+          <a:prstGeom prst="rect">
+            <a:avLst/>
+          </a:prstGeom>
+          <a:noFill/>
+        </p:spPr>
+        <p:txBody>
+          <a:bodyPr wrap="square" lIns="0" tIns="0" rIns="0" bIns="0">
+            <a:spAutoFit/>
+          </a:bodyPr>
+          <a:lstStyle/>
+          <a:p>
+            <a:pPr>
+              <a:spcAft>
+                <a:spcPts val="500"/>
+              </a:spcAft>
+              <a:defRPr sz="1700" b="1">
+                <a:solidFill>
+                  <a:srgbClr val="2F8F78"/>
+                </a:solidFill>
+                <a:latin typeface="Aptos"/>
+              </a:defRPr>
+            </a:pPr>
+            <a:r>
+              <a:t>03  Saldo disponible</a:t>
+            </a:r>
+          </a:p>
+        </p:txBody>
+      </p:sp>
+      <p:sp>
+        <p:nvSpPr>
+          <p:cNvPr id="17" name="TextBox 16"/>
+          <p:cNvSpPr txBox="1"/>
+          <p:nvPr/>
+        </p:nvSpPr>
+        <p:spPr>
+          <a:xfrm>
+            <a:off x="8129016" y="3520440"/>
+            <a:ext cx="3520440" cy="2258568"/>
+          </a:xfrm>
+          <a:prstGeom prst="rect">
+            <a:avLst/>
+          </a:prstGeom>
+          <a:noFill/>
+        </p:spPr>
+        <p:txBody>
+          <a:bodyPr wrap="square" lIns="0" tIns="0" rIns="0" bIns="0">
+            <a:spAutoFit/>
+          </a:bodyPr>
+          <a:lstStyle/>
+          <a:p>
+            <a:pPr>
+              <a:spcAft>
+                <a:spcPts val="500"/>
+              </a:spcAft>
+              <a:defRPr sz="1400" b="0">
+                <a:solidFill>
+                  <a:srgbClr val="333333"/>
+                </a:solidFill>
+                <a:latin typeface="Aptos"/>
+              </a:defRPr>
+            </a:pPr>
+            <a:r>
+              <a:t>Suma solo los días restantes de los períodos VIGENTES.</a:t>
+            </a:r>
+          </a:p>
+          <a:p>
+            <a:pPr>
+              <a:spcAft>
+                <a:spcPts val="500"/>
+              </a:spcAft>
+              <a:defRPr sz="1400" b="0">
+                <a:solidFill>
+                  <a:srgbClr val="333333"/>
+                </a:solidFill>
+                <a:latin typeface="Aptos"/>
+              </a:defRPr>
+            </a:pPr>
+            <a:r>
+              <a:t>Pueden coexistir 1 o hasta 2 períodos si el anterior aún no cumple sus 18 meses.</a:t>
+            </a:r>
+          </a:p>
+        </p:txBody>
+      </p:sp>
+      <p:sp>
+        <p:nvSpPr>
+          <p:cNvPr id="8" name="TextBox 7"/>
+          <p:cNvSpPr txBox="1"/>
+          <p:nvPr/>
+        </p:nvSpPr>
+        <p:spPr>
+          <a:xfrm>
+            <a:off x="594360" y="1989112"/>
+            <a:ext cx="11064240" cy="365760"/>
+          </a:xfrm>
+          <a:prstGeom prst="rect">
+            <a:avLst/>
+          </a:prstGeom>
+          <a:noFill/>
+        </p:spPr>
+        <p:txBody>
+          <a:bodyPr wrap="square" lIns="0" tIns="0" rIns="0" bIns="0">
+            <a:spAutoFit/>
+          </a:bodyPr>
+          <a:lstStyle/>
+          <a:p>
+            <a:pPr>
+              <a:spcAft>
+                <a:spcPts val="500"/>
+              </a:spcAft>
+              <a:defRPr sz="1600" b="1">
+                <a:solidFill>
+                  <a:srgbClr val="002D62"/>
+                </a:solidFill>
+                <a:latin typeface="Aptos"/>
+              </a:defRPr>
+            </a:pPr>
+            <a:r>
+              <a:rPr dirty="0"/>
+              <a:t>Al </a:t>
+            </a:r>
+            <a:r>
+              <a:rPr dirty="0" err="1"/>
+              <a:t>entrar</a:t>
+            </a:r>
+            <a:r>
+              <a:rPr dirty="0"/>
+              <a:t> al portal o </a:t>
+            </a:r>
+            <a:r>
+              <a:rPr dirty="0" err="1"/>
+              <a:t>consultar</a:t>
+            </a:r>
+            <a:r>
+              <a:rPr dirty="0"/>
+              <a:t> un </a:t>
+            </a:r>
+            <a:r>
+              <a:rPr dirty="0" err="1"/>
+              <a:t>saldo</a:t>
+            </a:r>
+            <a:r>
+              <a:rPr dirty="0"/>
+              <a:t>, el backend </a:t>
+            </a:r>
+            <a:r>
+              <a:rPr dirty="0" err="1"/>
+              <a:t>recalcula</a:t>
+            </a:r>
+            <a:r>
+              <a:rPr dirty="0"/>
+              <a:t> </a:t>
+            </a:r>
+            <a:r>
+              <a:rPr dirty="0" err="1"/>
+              <a:t>en</a:t>
+            </a:r>
+            <a:r>
+              <a:rPr dirty="0"/>
+              <a:t> </a:t>
+            </a:r>
+            <a:r>
+              <a:rPr dirty="0" err="1"/>
+              <a:t>tiempo</a:t>
+            </a:r>
+            <a:r>
+              <a:rPr dirty="0"/>
+              <a:t> real.</a:t>
+            </a:r>
+          </a:p>
+        </p:txBody>
+      </p:sp>
+    </p:spTree>
+  </p:cSld>
+  <p:clrMapOvr>
+    <a:masterClrMapping/>
+  </p:clrMapOvr>
+</p:sld>
+</file>
+
+<file path=ppt/slides/slide7.xml><?xml version="1.0" encoding="utf-8"?>
+<p:sld xmlns:a="http://schemas.openxmlformats.org/drawingml/2006/main" xmlns:r="http://schemas.openxmlformats.org/officeDocument/2006/relationships" xmlns:p="http://schemas.openxmlformats.org/presentationml/2006/main">
+  <p:cSld>
+    <p:bg>
+      <p:bgPr>
+        <a:solidFill>
+          <a:srgbClr val="FFFFFF"/>
+        </a:solidFill>
+        <a:effectLst/>
+      </p:bgPr>
+    </p:bg>
+    <p:spTree>
+      <p:nvGrpSpPr>
+        <p:cNvPr id="1" name=""/>
+        <p:cNvGrpSpPr/>
+        <p:nvPr/>
+      </p:nvGrpSpPr>
+      <p:grpSpPr>
+        <a:xfrm>
+          <a:off x="0" y="0"/>
+          <a:ext cx="0" cy="0"/>
+          <a:chOff x="0" y="0"/>
+          <a:chExt cx="0" cy="0"/>
+        </a:xfrm>
+      </p:grpSpPr>
+      <p:sp>
+        <p:nvSpPr>
+          <p:cNvPr id="2" name="Shape 0"/>
+          <p:cNvSpPr/>
+          <p:nvPr/>
+        </p:nvSpPr>
+        <p:spPr>
+          <a:xfrm>
+            <a:off x="0" y="0"/>
+            <a:ext cx="12191695" cy="146304"/>
+          </a:xfrm>
+          <a:prstGeom prst="rect">
+            <a:avLst/>
+          </a:prstGeom>
+          <a:solidFill>
+            <a:srgbClr val="002D62"/>
+          </a:solidFill>
+          <a:ln w="12700">
+            <a:solidFill>
+              <a:srgbClr val="002D62"/>
+            </a:solidFill>
+            <a:prstDash val="solid"/>
+          </a:ln>
+        </p:spPr>
+        <p:txBody>
+          <a:bodyPr/>
+          <a:lstStyle/>
+          <a:p>
+            <a:endParaRPr lang="es-MX"/>
+          </a:p>
+        </p:txBody>
+      </p:sp>
+      <p:sp>
+        <p:nvSpPr>
+          <p:cNvPr id="3" name="Text 1"/>
+          <p:cNvSpPr/>
+          <p:nvPr/>
+        </p:nvSpPr>
+        <p:spPr>
+          <a:xfrm>
+            <a:off x="502920" y="310896"/>
+            <a:ext cx="7315200" cy="201168"/>
+          </a:xfrm>
+          <a:prstGeom prst="rect">
+            <a:avLst/>
+          </a:prstGeom>
+          <a:noFill/>
+          <a:ln/>
+        </p:spPr>
+        <p:txBody>
+          <a:bodyPr wrap="square" lIns="0" tIns="0" rIns="0" bIns="0" rtlCol="0" anchor="ctr"/>
+          <a:lstStyle/>
+          <a:p>
+            <a:pPr marL="0" indent="0">
+              <a:buNone/>
+            </a:pPr>
+            <a:r>
+              <a:rPr lang="en-US" sz="900" b="1" kern="0" spc="120">
+                <a:solidFill>
+                  <a:srgbClr val="5B8296"/>
+                </a:solidFill>
+                <a:latin typeface="Aptos" pitchFamily="34" charset="0"/>
+                <a:ea typeface="Aptos" pitchFamily="34" charset="-122"/>
+                <a:cs typeface="Aptos" pitchFamily="34" charset="-120"/>
+              </a:rPr>
+              <a:t>MÓDULO 6 · SINCRONIZACIÓN Y AJUSTES</a:t>
+            </a:r>
+            <a:endParaRPr lang="en-US" sz="900"/>
+          </a:p>
+        </p:txBody>
+      </p:sp>
+      <p:sp>
+        <p:nvSpPr>
+          <p:cNvPr id="4" name="Text 2"/>
+          <p:cNvSpPr/>
+          <p:nvPr/>
+        </p:nvSpPr>
+        <p:spPr>
+          <a:xfrm>
+            <a:off x="502920" y="566928"/>
+            <a:ext cx="10515600" cy="420624"/>
+          </a:xfrm>
+          <a:prstGeom prst="rect">
+            <a:avLst/>
+          </a:prstGeom>
+          <a:noFill/>
+          <a:ln/>
+        </p:spPr>
+        <p:txBody>
+          <a:bodyPr wrap="square" lIns="0" tIns="0" rIns="0" bIns="0" rtlCol="0" anchor="ctr"/>
+          <a:lstStyle/>
+          <a:p>
+            <a:pPr marL="0" indent="0">
+              <a:buNone/>
+            </a:pPr>
+            <a:r>
+              <a:rPr lang="en-US" sz="2700" b="1">
+                <a:solidFill>
+                  <a:srgbClr val="002D62"/>
+                </a:solidFill>
+                <a:latin typeface="Aptos Display" pitchFamily="34" charset="0"/>
+                <a:ea typeface="Aptos Display" pitchFamily="34" charset="-122"/>
+                <a:cs typeface="Aptos Display" pitchFamily="34" charset="-120"/>
+              </a:rPr>
+              <a:t>¿Qué ocurre con las altas, bajas y reingresos?</a:t>
+            </a:r>
+            <a:endParaRPr lang="en-US" sz="2700"/>
+          </a:p>
+        </p:txBody>
+      </p:sp>
+      <p:pic>
+        <p:nvPicPr>
+          <p:cNvPr id="5" name="Image 0" descr="/mnt/data/work_jama/ppt/media/image1.png"/>
+          <p:cNvPicPr>
+            <a:picLocks noChangeAspect="1"/>
+          </p:cNvPicPr>
+          <p:nvPr/>
+        </p:nvPicPr>
+        <p:blipFill>
+          <a:blip r:embed="rId3"/>
+          <a:stretch>
+            <a:fillRect/>
+          </a:stretch>
+        </p:blipFill>
+        <p:spPr>
+          <a:xfrm>
+            <a:off x="10561320" y="338328"/>
+            <a:ext cx="1097280" cy="274320"/>
+          </a:xfrm>
+          <a:prstGeom prst="rect">
+            <a:avLst/>
+          </a:prstGeom>
+        </p:spPr>
+      </p:pic>
+      <p:sp>
+        <p:nvSpPr>
+          <p:cNvPr id="6" name="Text 3"/>
+          <p:cNvSpPr/>
+          <p:nvPr/>
+        </p:nvSpPr>
+        <p:spPr>
+          <a:xfrm>
+            <a:off x="11201400" y="6382512"/>
+            <a:ext cx="438912" cy="182880"/>
+          </a:xfrm>
+          <a:prstGeom prst="rect">
+            <a:avLst/>
+          </a:prstGeom>
+          <a:noFill/>
+          <a:ln/>
+        </p:spPr>
+        <p:txBody>
+          <a:bodyPr wrap="square" lIns="0" tIns="0" rIns="0" bIns="0" rtlCol="0" anchor="ctr"/>
+          <a:lstStyle/>
+          <a:p>
+            <a:pPr marL="0" indent="0" algn="r">
+              <a:buNone/>
+            </a:pPr>
+            <a:r>
+              <a:rPr lang="en-US" sz="800" b="1">
+                <a:solidFill>
+                  <a:srgbClr val="5B8296"/>
+                </a:solidFill>
+              </a:rPr>
+              <a:t>07</a:t>
+            </a:r>
+            <a:endParaRPr lang="en-US" sz="800"/>
+          </a:p>
+        </p:txBody>
+      </p:sp>
+      <p:sp>
+        <p:nvSpPr>
+          <p:cNvPr id="7" name="Shape 4"/>
+          <p:cNvSpPr/>
+          <p:nvPr/>
+        </p:nvSpPr>
+        <p:spPr>
+          <a:xfrm>
+            <a:off x="502920" y="6318504"/>
+            <a:ext cx="11155680" cy="1"/>
+          </a:xfrm>
+          <a:prstGeom prst="line">
+            <a:avLst/>
+          </a:prstGeom>
+          <a:noFill/>
+          <a:ln w="12700">
+            <a:solidFill>
+              <a:srgbClr val="D9E2E8"/>
+            </a:solidFill>
+            <a:prstDash val="solid"/>
+          </a:ln>
+        </p:spPr>
+        <p:txBody>
+          <a:bodyPr/>
+          <a:lstStyle/>
+          <a:p>
+            <a:endParaRPr lang="es-MX"/>
+          </a:p>
+        </p:txBody>
+      </p:sp>
+      <p:sp>
+        <p:nvSpPr>
+          <p:cNvPr id="8" name="Rectangle 7"/>
+          <p:cNvSpPr/>
+          <p:nvPr/>
+        </p:nvSpPr>
+        <p:spPr>
+          <a:xfrm>
+            <a:off x="502920" y="1325880"/>
+            <a:ext cx="5458968" cy="4526280"/>
+          </a:xfrm>
+          <a:prstGeom prst="rect">
+            <a:avLst/>
+          </a:prstGeom>
+          <a:solidFill>
+            <a:srgbClr val="F4F7F9"/>
+          </a:solidFill>
+          <a:ln>
+            <a:noFill/>
+          </a:ln>
+        </p:spPr>
+        <p:style>
+          <a:lnRef idx="1">
+            <a:schemeClr val="accent1"/>
+          </a:lnRef>
+          <a:fillRef idx="3">
+            <a:schemeClr val="accent1"/>
+          </a:fillRef>
+          <a:effectRef idx="2">
+            <a:schemeClr val="accent1"/>
+          </a:effectRef>
+          <a:fontRef idx="minor">
+            <a:schemeClr val="lt1"/>
+          </a:fontRef>
+        </p:style>
+        <p:txBody>
+          <a:bodyPr rtlCol="0" anchor="ctr"/>
+          <a:lstStyle/>
+          <a:p>
+            <a:pPr algn="ctr"/>
+            <a:endParaRPr/>
+          </a:p>
+        </p:txBody>
+      </p:sp>
+      <p:sp>
+        <p:nvSpPr>
+          <p:cNvPr id="9" name="Rectangle 8"/>
+          <p:cNvSpPr/>
+          <p:nvPr/>
+        </p:nvSpPr>
+        <p:spPr>
+          <a:xfrm>
+            <a:off x="6199632" y="1325880"/>
+            <a:ext cx="5458968" cy="4526280"/>
+          </a:xfrm>
+          <a:prstGeom prst="rect">
+            <a:avLst/>
+          </a:prstGeom>
+          <a:solidFill>
+            <a:srgbClr val="F4F7F9"/>
+          </a:solidFill>
+          <a:ln>
+            <a:noFill/>
+          </a:ln>
+        </p:spPr>
+        <p:style>
+          <a:lnRef idx="1">
+            <a:schemeClr val="accent1"/>
+          </a:lnRef>
+          <a:fillRef idx="3">
+            <a:schemeClr val="accent1"/>
+          </a:fillRef>
+          <a:effectRef idx="2">
+            <a:schemeClr val="accent1"/>
+          </a:effectRef>
+          <a:fontRef idx="minor">
+            <a:schemeClr val="lt1"/>
+          </a:fontRef>
+        </p:style>
+        <p:txBody>
+          <a:bodyPr rtlCol="0" anchor="ctr"/>
+          <a:lstStyle/>
+          <a:p>
+            <a:pPr algn="ctr"/>
+            <a:endParaRPr/>
+          </a:p>
+        </p:txBody>
+      </p:sp>
+      <p:sp>
+        <p:nvSpPr>
+          <p:cNvPr id="10" name="TextBox 9"/>
+          <p:cNvSpPr txBox="1"/>
+          <p:nvPr/>
+        </p:nvSpPr>
+        <p:spPr>
+          <a:xfrm>
+            <a:off x="777240" y="1627632"/>
+            <a:ext cx="4910328" cy="438912"/>
+          </a:xfrm>
+          <a:prstGeom prst="rect">
+            <a:avLst/>
+          </a:prstGeom>
+          <a:noFill/>
+        </p:spPr>
+        <p:txBody>
+          <a:bodyPr wrap="square" lIns="0" tIns="0" rIns="0" bIns="0">
+            <a:spAutoFit/>
+          </a:bodyPr>
+          <a:lstStyle/>
+          <a:p>
+            <a:pPr>
+              <a:spcAft>
+                <a:spcPts val="500"/>
+              </a:spcAft>
+              <a:defRPr sz="1800" b="1">
+                <a:solidFill>
+                  <a:srgbClr val="002D62"/>
+                </a:solidFill>
+                <a:latin typeface="Aptos"/>
+              </a:defRPr>
+            </a:pPr>
+            <a:r>
+              <a:t>Sincronización con nómina</a:t>
+            </a:r>
+          </a:p>
+        </p:txBody>
+      </p:sp>
+      <p:sp>
+        <p:nvSpPr>
+          <p:cNvPr id="11" name="TextBox 10"/>
+          <p:cNvSpPr txBox="1"/>
+          <p:nvPr/>
+        </p:nvSpPr>
+        <p:spPr>
+          <a:xfrm>
+            <a:off x="777240" y="2212848"/>
+            <a:ext cx="4892040" cy="603504"/>
+          </a:xfrm>
+          <a:prstGeom prst="rect">
+            <a:avLst/>
+          </a:prstGeom>
+          <a:noFill/>
+        </p:spPr>
+        <p:txBody>
+          <a:bodyPr wrap="square" lIns="0" tIns="0" rIns="0" bIns="0">
+            <a:spAutoFit/>
+          </a:bodyPr>
+          <a:lstStyle/>
+          <a:p>
+            <a:pPr>
+              <a:spcAft>
+                <a:spcPts val="500"/>
+              </a:spcAft>
+              <a:defRPr sz="1500" b="1">
+                <a:solidFill>
+                  <a:srgbClr val="5B8296"/>
+                </a:solidFill>
+                <a:latin typeface="Aptos"/>
+              </a:defRPr>
+            </a:pPr>
+            <a:r>
+              <a:t>“Sincronizar desde CONTPAQi® Nóminas”</a:t>
+            </a:r>
+          </a:p>
+        </p:txBody>
+      </p:sp>
+      <p:sp>
+        <p:nvSpPr>
+          <p:cNvPr id="12" name="TextBox 11"/>
+          <p:cNvSpPr txBox="1"/>
+          <p:nvPr/>
+        </p:nvSpPr>
+        <p:spPr>
+          <a:xfrm>
+            <a:off x="777240" y="2907792"/>
+            <a:ext cx="4800600" cy="692497"/>
+          </a:xfrm>
+          <a:prstGeom prst="rect">
+            <a:avLst/>
+          </a:prstGeom>
+          <a:noFill/>
+        </p:spPr>
+        <p:txBody>
+          <a:bodyPr wrap="square" lIns="0" tIns="0" rIns="0" bIns="0">
+            <a:spAutoFit/>
+          </a:bodyPr>
+          <a:lstStyle/>
+          <a:p>
+            <a:pPr>
+              <a:spcAft>
+                <a:spcPts val="500"/>
+              </a:spcAft>
+              <a:defRPr sz="1500" b="0">
+                <a:solidFill>
+                  <a:srgbClr val="333333"/>
+                </a:solidFill>
+                <a:latin typeface="Aptos"/>
+              </a:defRPr>
+            </a:pPr>
+            <a:r>
+              <a:rPr dirty="0"/>
+              <a:t>Al pulsar el </a:t>
+            </a:r>
+            <a:r>
+              <a:rPr dirty="0" err="1"/>
+              <a:t>botón</a:t>
+            </a:r>
+            <a:r>
+              <a:rPr dirty="0"/>
+              <a:t>, la </a:t>
+            </a:r>
+            <a:r>
+              <a:rPr dirty="0" err="1"/>
+              <a:t>aplicación</a:t>
+            </a:r>
+            <a:r>
+              <a:rPr dirty="0"/>
+              <a:t> </a:t>
+            </a:r>
+            <a:r>
+              <a:rPr dirty="0" err="1"/>
+              <a:t>actualiza</a:t>
+            </a:r>
+            <a:r>
+              <a:rPr dirty="0"/>
+              <a:t> </a:t>
+            </a:r>
+            <a:r>
+              <a:rPr dirty="0" err="1"/>
+              <a:t>desde</a:t>
+            </a:r>
+            <a:r>
+              <a:rPr dirty="0"/>
+              <a:t> </a:t>
+            </a:r>
+            <a:r>
+              <a:rPr lang="es-ES" dirty="0"/>
+              <a:t>NOMIPAC</a:t>
+            </a:r>
+            <a:r>
+              <a:rPr dirty="0"/>
+              <a:t> las </a:t>
+            </a:r>
+            <a:r>
+              <a:rPr dirty="0" err="1"/>
+              <a:t>fechas</a:t>
+            </a:r>
+            <a:r>
+              <a:rPr dirty="0"/>
+              <a:t> de </a:t>
+            </a:r>
+            <a:r>
+              <a:rPr dirty="0" err="1"/>
+              <a:t>alta</a:t>
+            </a:r>
+            <a:r>
+              <a:rPr dirty="0"/>
+              <a:t>, los </a:t>
+            </a:r>
+            <a:r>
+              <a:rPr dirty="0" err="1"/>
+              <a:t>puestos</a:t>
+            </a:r>
+            <a:r>
+              <a:rPr dirty="0"/>
+              <a:t> y el </a:t>
+            </a:r>
+            <a:r>
+              <a:rPr dirty="0" err="1"/>
+              <a:t>estatus</a:t>
+            </a:r>
+            <a:r>
+              <a:rPr dirty="0"/>
+              <a:t> del </a:t>
+            </a:r>
+            <a:r>
+              <a:rPr dirty="0" err="1"/>
+              <a:t>colaborador</a:t>
+            </a:r>
+            <a:r>
+              <a:rPr dirty="0"/>
+              <a:t>.</a:t>
+            </a:r>
+          </a:p>
+        </p:txBody>
+      </p:sp>
+      <p:sp>
+        <p:nvSpPr>
+          <p:cNvPr id="13" name="TextBox 12"/>
+          <p:cNvSpPr txBox="1"/>
+          <p:nvPr/>
+        </p:nvSpPr>
+        <p:spPr>
+          <a:xfrm>
+            <a:off x="777240" y="4087368"/>
+            <a:ext cx="4754880" cy="274320"/>
+          </a:xfrm>
+          <a:prstGeom prst="rect">
+            <a:avLst/>
+          </a:prstGeom>
+          <a:noFill/>
+        </p:spPr>
+        <p:txBody>
+          <a:bodyPr wrap="square" lIns="0" tIns="0" rIns="0" bIns="0">
+            <a:spAutoFit/>
+          </a:bodyPr>
+          <a:lstStyle/>
+          <a:p>
+            <a:pPr>
+              <a:spcAft>
+                <a:spcPts val="500"/>
+              </a:spcAft>
+              <a:defRPr sz="1300" b="1">
+                <a:solidFill>
+                  <a:srgbClr val="002D62"/>
+                </a:solidFill>
+                <a:latin typeface="Aptos"/>
+              </a:defRPr>
+            </a:pPr>
+            <a:r>
+              <a:t>Altas y reingresos</a:t>
+            </a:r>
+          </a:p>
+        </p:txBody>
+      </p:sp>
+      <p:sp>
+        <p:nvSpPr>
+          <p:cNvPr id="14" name="TextBox 13"/>
+          <p:cNvSpPr txBox="1"/>
+          <p:nvPr/>
+        </p:nvSpPr>
+        <p:spPr>
+          <a:xfrm>
+            <a:off x="777240" y="4480560"/>
+            <a:ext cx="4800600" cy="658368"/>
+          </a:xfrm>
+          <a:prstGeom prst="rect">
+            <a:avLst/>
+          </a:prstGeom>
+          <a:noFill/>
+        </p:spPr>
+        <p:txBody>
+          <a:bodyPr wrap="square" lIns="0" tIns="0" rIns="0" bIns="0">
+            <a:spAutoFit/>
+          </a:bodyPr>
+          <a:lstStyle/>
+          <a:p>
+            <a:pPr>
+              <a:spcAft>
+                <a:spcPts val="500"/>
+              </a:spcAft>
+              <a:defRPr sz="1500" b="0">
+                <a:solidFill>
+                  <a:srgbClr val="333333"/>
+                </a:solidFill>
+                <a:latin typeface="Aptos"/>
+              </a:defRPr>
+            </a:pPr>
+            <a:r>
+              <a:t>Una nueva fecha de alta o reingreso inicializa sus períodos automáticamente.</a:t>
+            </a:r>
+          </a:p>
+        </p:txBody>
+      </p:sp>
+      <p:sp>
+        <p:nvSpPr>
+          <p:cNvPr id="15" name="TextBox 14"/>
+          <p:cNvSpPr txBox="1"/>
+          <p:nvPr/>
+        </p:nvSpPr>
+        <p:spPr>
+          <a:xfrm>
+            <a:off x="777240" y="5257800"/>
+            <a:ext cx="4800600" cy="438912"/>
+          </a:xfrm>
+          <a:prstGeom prst="rect">
+            <a:avLst/>
+          </a:prstGeom>
+          <a:noFill/>
+        </p:spPr>
+        <p:txBody>
+          <a:bodyPr wrap="square" lIns="0" tIns="0" rIns="0" bIns="0">
+            <a:spAutoFit/>
+          </a:bodyPr>
+          <a:lstStyle/>
+          <a:p>
+            <a:pPr>
+              <a:spcAft>
+                <a:spcPts val="500"/>
+              </a:spcAft>
+              <a:defRPr sz="1200" b="0">
+                <a:solidFill>
+                  <a:srgbClr val="5B8296"/>
+                </a:solidFill>
+                <a:latin typeface="Aptos"/>
+              </a:defRPr>
+            </a:pPr>
+            <a:r>
+              <a:t>Las bajas se reflejan mediante la actualización del estatus desde nómina.</a:t>
+            </a:r>
+          </a:p>
+        </p:txBody>
+      </p:sp>
+      <p:sp>
+        <p:nvSpPr>
+          <p:cNvPr id="16" name="TextBox 15"/>
+          <p:cNvSpPr txBox="1"/>
+          <p:nvPr/>
+        </p:nvSpPr>
+        <p:spPr>
+          <a:xfrm>
+            <a:off x="6473952" y="1627632"/>
+            <a:ext cx="4910328" cy="438912"/>
+          </a:xfrm>
+          <a:prstGeom prst="rect">
+            <a:avLst/>
+          </a:prstGeom>
+          <a:noFill/>
+        </p:spPr>
+        <p:txBody>
+          <a:bodyPr wrap="square" lIns="0" tIns="0" rIns="0" bIns="0">
+            <a:spAutoFit/>
+          </a:bodyPr>
+          <a:lstStyle/>
+          <a:p>
+            <a:pPr>
+              <a:spcAft>
+                <a:spcPts val="500"/>
+              </a:spcAft>
+              <a:defRPr sz="1800" b="1">
+                <a:solidFill>
+                  <a:srgbClr val="2F8F78"/>
+                </a:solidFill>
+                <a:latin typeface="Aptos"/>
+              </a:defRPr>
+            </a:pPr>
+            <a:r>
+              <a:t>Saldos capturados por DO</a:t>
+            </a:r>
+          </a:p>
+        </p:txBody>
+      </p:sp>
+      <p:sp>
+        <p:nvSpPr>
+          <p:cNvPr id="17" name="TextBox 16"/>
+          <p:cNvSpPr txBox="1"/>
+          <p:nvPr/>
+        </p:nvSpPr>
+        <p:spPr>
+          <a:xfrm>
+            <a:off x="6473952" y="2212848"/>
+            <a:ext cx="4892040" cy="347472"/>
+          </a:xfrm>
+          <a:prstGeom prst="rect">
+            <a:avLst/>
+          </a:prstGeom>
+          <a:noFill/>
+        </p:spPr>
+        <p:txBody>
+          <a:bodyPr wrap="square" lIns="0" tIns="0" rIns="0" bIns="0">
+            <a:spAutoFit/>
+          </a:bodyPr>
+          <a:lstStyle/>
+          <a:p>
+            <a:pPr>
+              <a:spcAft>
+                <a:spcPts val="500"/>
+              </a:spcAft>
+              <a:defRPr sz="1500" b="1">
+                <a:solidFill>
+                  <a:srgbClr val="5B8296"/>
+                </a:solidFill>
+                <a:latin typeface="Aptos"/>
+              </a:defRPr>
+            </a:pPr>
+            <a:r>
+              <a:t>Carga inicial o ajuste manual</a:t>
+            </a:r>
+          </a:p>
+        </p:txBody>
+      </p:sp>
+      <p:sp>
+        <p:nvSpPr>
+          <p:cNvPr id="18" name="TextBox 17"/>
+          <p:cNvSpPr txBox="1"/>
+          <p:nvPr/>
+        </p:nvSpPr>
+        <p:spPr>
+          <a:xfrm>
+            <a:off x="6473952" y="2907792"/>
+            <a:ext cx="4800600" cy="960120"/>
+          </a:xfrm>
+          <a:prstGeom prst="rect">
+            <a:avLst/>
+          </a:prstGeom>
+          <a:noFill/>
+        </p:spPr>
+        <p:txBody>
+          <a:bodyPr wrap="square" lIns="0" tIns="0" rIns="0" bIns="0">
+            <a:spAutoFit/>
+          </a:bodyPr>
+          <a:lstStyle/>
+          <a:p>
+            <a:pPr>
+              <a:spcAft>
+                <a:spcPts val="500"/>
+              </a:spcAft>
+              <a:defRPr sz="1500" b="0">
+                <a:solidFill>
+                  <a:srgbClr val="333333"/>
+                </a:solidFill>
+                <a:latin typeface="Aptos"/>
+              </a:defRPr>
+            </a:pPr>
+            <a:r>
+              <a:t>Desarrollo Organizacional puede cargar saldos iniciales mediante la plantilla de Excel o fijar un saldo manual en la ficha.</a:t>
+            </a:r>
+          </a:p>
+        </p:txBody>
+      </p:sp>
+      <p:sp>
+        <p:nvSpPr>
+          <p:cNvPr id="19" name="TextBox 18"/>
+          <p:cNvSpPr txBox="1"/>
+          <p:nvPr/>
+        </p:nvSpPr>
+        <p:spPr>
+          <a:xfrm>
+            <a:off x="6473952" y="4087368"/>
+            <a:ext cx="4800600" cy="347472"/>
+          </a:xfrm>
+          <a:prstGeom prst="rect">
+            <a:avLst/>
+          </a:prstGeom>
+          <a:noFill/>
+        </p:spPr>
+        <p:txBody>
+          <a:bodyPr wrap="square" lIns="0" tIns="0" rIns="0" bIns="0">
+            <a:spAutoFit/>
+          </a:bodyPr>
+          <a:lstStyle/>
+          <a:p>
+            <a:pPr>
+              <a:spcAft>
+                <a:spcPts val="500"/>
+              </a:spcAft>
+              <a:defRPr sz="1300" b="1">
+                <a:solidFill>
+                  <a:srgbClr val="2F8F78"/>
+                </a:solidFill>
+                <a:latin typeface="Aptos"/>
+              </a:defRPr>
+            </a:pPr>
+            <a:r>
+              <a:t>El sistema respeta los días capturados</a:t>
+            </a:r>
+          </a:p>
+        </p:txBody>
+      </p:sp>
+      <p:sp>
+        <p:nvSpPr>
+          <p:cNvPr id="20" name="TextBox 19"/>
+          <p:cNvSpPr txBox="1"/>
+          <p:nvPr/>
+        </p:nvSpPr>
+        <p:spPr>
+          <a:xfrm>
+            <a:off x="6473952" y="4562856"/>
+            <a:ext cx="4800600" cy="804672"/>
+          </a:xfrm>
+          <a:prstGeom prst="rect">
+            <a:avLst/>
+          </a:prstGeom>
+          <a:noFill/>
+        </p:spPr>
+        <p:txBody>
+          <a:bodyPr wrap="square" lIns="0" tIns="0" rIns="0" bIns="0">
+            <a:spAutoFit/>
+          </a:bodyPr>
+          <a:lstStyle/>
+          <a:p>
+            <a:pPr>
+              <a:spcAft>
+                <a:spcPts val="500"/>
+              </a:spcAft>
+              <a:defRPr sz="1500" b="0">
+                <a:solidFill>
+                  <a:srgbClr val="333333"/>
+                </a:solidFill>
+                <a:latin typeface="Aptos"/>
+              </a:defRPr>
+            </a:pPr>
+            <a:r>
+              <a:t>Solo proyecta los ciclos futuros conforme se cumplen nuevos aniversarios.</a:t>
+            </a:r>
           </a:p>
         </p:txBody>
       </p:sp>
@@ -9464,7 +11632,7 @@
 </file>
 
 <file path=ppt/theme/theme2.xml><?xml version="1.0" encoding="utf-8"?>
-<a:theme xmlns:a="http://schemas.openxmlformats.org/drawingml/2006/main" name="Office Theme">
+<a:theme xmlns:a="http://schemas.openxmlformats.org/drawingml/2006/main" name="Tema de Office">
   <a:themeElements>
     <a:clrScheme name="Office">
       <a:dk1>
@@ -9474,39 +11642,39 @@
         <a:sysClr val="window" lastClr="FFFFFF"/>
       </a:lt1>
       <a:dk2>
-        <a:srgbClr val="44546A"/>
+        <a:srgbClr val="0E2841"/>
       </a:dk2>
       <a:lt2>
-        <a:srgbClr val="E7E6E6"/>
+        <a:srgbClr val="E8E8E8"/>
       </a:lt2>
       <a:accent1>
-        <a:srgbClr val="4472C4"/>
+        <a:srgbClr val="156082"/>
       </a:accent1>
       <a:accent2>
-        <a:srgbClr val="ED7D31"/>
+        <a:srgbClr val="E97132"/>
       </a:accent2>
       <a:accent3>
-        <a:srgbClr val="A5A5A5"/>
+        <a:srgbClr val="196B24"/>
       </a:accent3>
       <a:accent4>
-        <a:srgbClr val="FFC000"/>
+        <a:srgbClr val="0F9ED5"/>
       </a:accent4>
       <a:accent5>
-        <a:srgbClr val="5B9BD5"/>
+        <a:srgbClr val="A02B93"/>
       </a:accent5>
       <a:accent6>
-        <a:srgbClr val="70AD47"/>
+        <a:srgbClr val="4EA72E"/>
       </a:accent6>
       <a:hlink>
-        <a:srgbClr val="0563C1"/>
+        <a:srgbClr val="467886"/>
       </a:hlink>
       <a:folHlink>
-        <a:srgbClr val="954F72"/>
+        <a:srgbClr val="96607D"/>
       </a:folHlink>
     </a:clrScheme>
     <a:fontScheme name="Office">
       <a:majorFont>
-        <a:latin typeface="Aptos Display"/>
+        <a:latin typeface="Aptos Display" panose="02110004020202020204"/>
         <a:ea typeface=""/>
         <a:cs typeface=""/>
         <a:font script="Jpan" typeface="游ゴシック Light"/>
@@ -9558,7 +11726,7 @@
         <a:font script="Tfng" typeface="Ebrima"/>
       </a:majorFont>
       <a:minorFont>
-        <a:latin typeface="Aptos"/>
+        <a:latin typeface="Aptos" panose="02110004020202020204"/>
         <a:ea typeface=""/>
         <a:cs typeface=""/>
         <a:font script="Jpan" typeface="游ゴシック"/>
@@ -9669,13 +11837,6 @@
         </a:gradFill>
       </a:fillStyleLst>
       <a:lnStyleLst>
-        <a:ln w="6350" cap="flat" cmpd="sng" algn="ctr">
-          <a:solidFill>
-            <a:schemeClr val="phClr"/>
-          </a:solidFill>
-          <a:prstDash val="solid"/>
-          <a:miter lim="800000"/>
-        </a:ln>
         <a:ln w="12700" cap="flat" cmpd="sng" algn="ctr">
           <a:solidFill>
             <a:schemeClr val="phClr"/>
@@ -9684,6 +11845,13 @@
           <a:miter lim="800000"/>
         </a:ln>
         <a:ln w="19050" cap="flat" cmpd="sng" algn="ctr">
+          <a:solidFill>
+            <a:schemeClr val="phClr"/>
+          </a:solidFill>
+          <a:prstDash val="solid"/>
+          <a:miter lim="800000"/>
+        </a:ln>
+        <a:ln w="25400" cap="flat" cmpd="sng" algn="ctr">
           <a:solidFill>
             <a:schemeClr val="phClr"/>
           </a:solidFill>
@@ -9748,11 +11916,31 @@
       </a:bgFillStyleLst>
     </a:fmtScheme>
   </a:themeElements>
-  <a:objectDefaults/>
+  <a:objectDefaults>
+    <a:lnDef>
+      <a:spPr/>
+      <a:bodyPr/>
+      <a:lstStyle/>
+      <a:style>
+        <a:lnRef idx="2">
+          <a:schemeClr val="accent1"/>
+        </a:lnRef>
+        <a:fillRef idx="0">
+          <a:schemeClr val="accent1"/>
+        </a:fillRef>
+        <a:effectRef idx="1">
+          <a:schemeClr val="accent1"/>
+        </a:effectRef>
+        <a:fontRef idx="minor">
+          <a:schemeClr val="tx1"/>
+        </a:fontRef>
+      </a:style>
+    </a:lnDef>
+  </a:objectDefaults>
   <a:extraClrSchemeLst/>
   <a:extLst>
     <a:ext uri="{05A4C25C-085E-4340-85A3-A5531E510DB2}">
-      <thm15:themeFamily xmlns:thm15="http://schemas.microsoft.com/office/thememl/2012/main" name="Office Theme" id="{62F939B6-93AF-4DB8-9C6B-D6C7DFDC589F}" vid="{4A3C46E8-61CC-4603-A589-7422A47A8E4A}"/>
+      <thm15:themeFamily xmlns:thm15="http://schemas.microsoft.com/office/thememl/2012/main" name="Office Theme" id="{2E142A2C-CD16-42D6-873A-C26D2A0506FA}" vid="{1BDDFF52-6CD6-40A5-AB3C-68EB2F1E4D0A}"/>
     </a:ext>
   </a:extLst>
 </a:theme>

</xml_diff>